<commit_message>
One-command compose stack, backend fetch script, README verification path, conformance matrix and threat model
Also: Postman bonus scenario uses the declined email claim and sends prompt=consent and audience;
stale picture/hCaptcha/timing/section-number claims corrected across docs and deck; CI workflow
for the SDK tests; organiser PDF and pyc untracked.

Signed-off-by: Anurag Thakur <anuragthakur2102@gmail.com>
</commit_message>
<xml_diff>
--- a/docs/pitch-deck.pptx
+++ b/docs/pitch-deck.pptx
@@ -2587,7 +2587,7 @@
                   <a:schemeClr val="tx2"/>
                 </a:solidFill>
               </a:rPr>
-              <a:t>upstream-ready pull requests</a:t>
+              <a:t>upstream pull requests</a:t>
             </a:r>
             <a:endParaRPr lang="en-US" sz="1200" dirty="0"/>
           </a:p>
@@ -3455,7 +3455,7 @@
                   <a:schemeClr val="tx1"/>
                 </a:solidFill>
               </a:rPr>
-              <a:t>thunder-id/thunderid: provider contracts, device-secret issuance, token exchange with device-secret actor tokens, consent hook (3 commits, DCO)</a:t>
+              <a:t>thunder-id/thunderid: provider contracts, device-secret issuance, token exchange with device-secret actor tokens, consent hook (DCO signed-off)</a:t>
             </a:r>
             <a:endParaRPr lang="en-US" sz="1150" dirty="0"/>
           </a:p>
@@ -3473,7 +3473,7 @@
                   <a:schemeClr val="tx1"/>
                 </a:solidFill>
               </a:rPr>
-              <a:t>mosip/esignet develop-go: DeviceSecretProvider, derived consent, token_exchange clients, config, docs (5 commits, DCO)</a:t>
+              <a:t>mosip/esignet develop-go: DeviceSecretProvider, derived consent, token_exchange clients, config, docs (DCO signed-off)</a:t>
             </a:r>
             <a:endParaRPr lang="en-US" sz="1150" dirty="0"/>
           </a:p>
@@ -3491,7 +3491,7 @@
                   <a:schemeClr val="tx1"/>
                 </a:solidFill>
               </a:rPr>
-              <a:t>Plus eSignet community fixes: #2555 (consent purposeName), #2590 (keycloak scope)</a:t>
+              <a:t>Plus an eSignet community fix: #2555 (unrecognised consent purposeName)</a:t>
             </a:r>
             <a:endParaRPr lang="en-US" sz="1150" dirty="0"/>
           </a:p>
@@ -7518,7 +7518,7 @@
                   <a:schemeClr val="tx2"/>
                 </a:solidFill>
               </a:rPr>
-              <a:t>“Signed in silently in 420 ms”</a:t>
+              <a:t>“Signed in silently in 185 ms”</a:t>
             </a:r>
             <a:endParaRPr lang="en-US" sz="1200" dirty="0"/>
           </a:p>
@@ -8495,7 +8495,7 @@
                   <a:schemeClr val="bg1"/>
                 </a:solidFill>
               </a:rPr>
-              <a:t>openid profile</a:t>
+              <a:t>openid email</a:t>
             </a:r>
             <a:endParaRPr lang="en-US" sz="1200" dirty="0"/>
           </a:p>
@@ -8582,7 +8582,7 @@
                   <a:schemeClr val="bg1"/>
                 </a:solidFill>
               </a:rPr>
-              <a:t>profile releases name + picture</a:t>
+              <a:t>email was declined</a:t>
             </a:r>
             <a:endParaRPr lang="en-US" sz="1200" dirty="0"/>
           </a:p>
@@ -8596,7 +8596,7 @@
                   <a:schemeClr val="bg1"/>
                 </a:solidFill>
               </a:rPr>
-              <a:t>user unticked picture</a:t>
+              <a:t>on the super app's consent</a:t>
             </a:r>
             <a:endParaRPr lang="en-US" sz="1200" dirty="0"/>
           </a:p>
@@ -8697,7 +8697,7 @@
                   <a:schemeClr val="bg1"/>
                 </a:solidFill>
               </a:rPr>
-              <a:t>“claims not consented: picture”</a:t>
+              <a:t>“claims not consented: email”</a:t>
             </a:r>
             <a:endParaRPr lang="en-US" sz="1200" dirty="0"/>
           </a:p>
@@ -8774,7 +8774,7 @@
                   <a:schemeClr val="bg1"/>
                 </a:solidFill>
               </a:rPr>
-              <a:t>openid email</a:t>
+              <a:t>openid profile</a:t>
             </a:r>
             <a:endParaRPr lang="en-US" sz="1200" dirty="0"/>
           </a:p>
@@ -8861,7 +8861,7 @@
                   <a:schemeClr val="bg1"/>
                 </a:solidFill>
               </a:rPr>
-              <a:t>email accepted at the</a:t>
+              <a:t>name was accepted at the</a:t>
             </a:r>
             <a:endParaRPr lang="en-US" sz="1200" dirty="0"/>
           </a:p>

</xml_diff>

<commit_message>
Pitch deck built from the repository generator; image alt text no longer carries file paths
Signed-off-by: Anurag Thakur <anuragthakur2102@gmail.com>
</commit_message>
<xml_diff>
--- a/docs/pitch-deck.pptx
+++ b/docs/pitch-deck.pptx
@@ -119,18 +119,18 @@
   <p:extLst>
     <p:ext uri="{521415D9-36F7-43E2-AB2F-B90AF26B5E84}">
       <p14:sectionLst xmlns:p14="http://schemas.microsoft.com/office/powerpoint/2010/main">
-        <p14:section name="Opening" id="{46557425-bb4a-f652-f6db-bdc9fd206e17}">
+        <p14:section name="Opening" id="{c6771ab9-2a00-2712-15da-05564694dd57}">
           <p14:sldIdLst>
             <p14:sldId id="256"/>
           </p14:sldIdLst>
         </p14:section>
-        <p14:section name="Problem and approach" id="{542c0045-c9ea-024b-fdda-9a334b51a0c6}">
+        <p14:section name="Problem and approach" id="{f50fb31a-c41d-fc37-3767-ed3e16544678}">
           <p14:sldIdLst>
             <p14:sldId id="257"/>
             <p14:sldId id="258"/>
           </p14:sldIdLst>
         </p14:section>
-        <p14:section name="How it works" id="{8feaeda9-11d3-4578-efc2-2f82c96c77c6}">
+        <p14:section name="How it works" id="{1f390406-03cf-4246-31ba-7204b15732f1}">
           <p14:sldIdLst>
             <p14:sldId id="259"/>
             <p14:sldId id="260"/>
@@ -139,7 +139,7 @@
             <p14:sldId id="263"/>
           </p14:sldIdLst>
         </p14:section>
-        <p14:section name="Delivery" id="{5f24828e-1f55-f624-88f6-a57a0b98b946}">
+        <p14:section name="Delivery" id="{77a5b9cd-377f-c549-4089-f1be7ab92e06}">
           <p14:sldIdLst>
             <p14:sldId id="264"/>
             <p14:sldId id="265"/>
@@ -147,7 +147,7 @@
             <p14:sldId id="267"/>
           </p14:sldIdLst>
         </p14:section>
-        <p14:section name="Closing" id="{c4df5e46-f01e-1267-f845-4a5d4314142b}">
+        <p14:section name="Closing" id="{434ee3a0-9979-fd11-f2ee-c0339ba76aab}">
           <p14:sldIdLst>
             <p14:sldId id="268"/>
           </p14:sldIdLst>
@@ -3714,7 +3714,7 @@
       </p:sp>
       <p:pic>
         <p:nvPicPr>
-          <p:cNvPr id="11004" name="Vendor Wallet signed in" descr="/private/tmp/claude-501/-Users-anurag-MOSIP-hack/658be82f-9963-4882-b3de-0a07f144bfe8/scratchpad/deck/crop/wallet-signed-in.png">    </p:cNvPr>
+          <p:cNvPr id="11004" name="Vendor Wallet signed in" descr="Vendor Wallet signed in">    </p:cNvPr>
           <p:cNvPicPr>
             <a:picLocks noChangeAspect="1"/>
           </p:cNvPicPr>
@@ -3760,7 +3760,7 @@
       </p:sp>
       <p:pic>
         <p:nvPicPr>
-          <p:cNvPr id="11006" name="Vendor Health signed in silently" descr="/private/tmp/claude-501/-Users-anurag-MOSIP-hack/658be82f-9963-4882-b3de-0a07f144bfe8/scratchpad/deck/crop/health-signed-in-silently.png">    </p:cNvPr>
+          <p:cNvPr id="11006" name="Vendor Health signed in silently" descr="Vendor Health signed in silently">    </p:cNvPr>
           <p:cNvPicPr>
             <a:picLocks noChangeAspect="1"/>
           </p:cNvPicPr>
@@ -11596,7 +11596,7 @@
       </p:sp>
       <p:pic>
         <p:nvPicPr>
-          <p:cNvPr id="6019" name="Vendor Health signed in silently" descr="/private/tmp/claude-501/-Users-anurag-MOSIP-hack/658be82f-9963-4882-b3de-0a07f144bfe8/scratchpad/deck/crop/health-signed-in-silently.png">    </p:cNvPr>
+          <p:cNvPr id="6019" name="Vendor Health signed in silently" descr="Vendor Health signed in silently">    </p:cNvPr>
           <p:cNvPicPr>
             <a:picLocks noChangeAspect="1"/>
           </p:cNvPicPr>

</xml_diff>

<commit_message>
Pitch deck renders reliably in macOS Quick Look: plain shapes as RGB text boxes, square corners, deck-unique ids
Signed-off-by: Anurag Thakur <anuragthakur2102@gmail.com>
</commit_message>
<xml_diff>
--- a/docs/pitch-deck.pptx
+++ b/docs/pitch-deck.pptx
@@ -119,18 +119,18 @@
   <p:extLst>
     <p:ext uri="{521415D9-36F7-43E2-AB2F-B90AF26B5E84}">
       <p14:sectionLst xmlns:p14="http://schemas.microsoft.com/office/powerpoint/2010/main">
-        <p14:section name="Opening" id="{c6771ab9-2a00-2712-15da-05564694dd57}">
+        <p14:section name="Opening" id="{f4ce784b-7097-de93-c67e-683490c317da}">
           <p14:sldIdLst>
             <p14:sldId id="256"/>
           </p14:sldIdLst>
         </p14:section>
-        <p14:section name="Problem and approach" id="{f50fb31a-c41d-fc37-3767-ed3e16544678}">
+        <p14:section name="Problem and approach" id="{ce003156-828d-0b8d-c4ba-1e2c28132b45}">
           <p14:sldIdLst>
             <p14:sldId id="257"/>
             <p14:sldId id="258"/>
           </p14:sldIdLst>
         </p14:section>
-        <p14:section name="How it works" id="{1f390406-03cf-4246-31ba-7204b15732f1}">
+        <p14:section name="How it works" id="{8f8edc19-26f0-2149-f615-f814e8b80fc0}">
           <p14:sldIdLst>
             <p14:sldId id="259"/>
             <p14:sldId id="260"/>
@@ -139,7 +139,7 @@
             <p14:sldId id="263"/>
           </p14:sldIdLst>
         </p14:section>
-        <p14:section name="Delivery" id="{77a5b9cd-377f-c549-4089-f1be7ab92e06}">
+        <p14:section name="Delivery" id="{4b84f6fe-337c-5f09-34e3-e3b6e4d3957b}">
           <p14:sldIdLst>
             <p14:sldId id="264"/>
             <p14:sldId id="265"/>
@@ -147,7 +147,7 @@
             <p14:sldId id="267"/>
           </p14:sldIdLst>
         </p14:section>
-        <p14:section name="Closing" id="{434ee3a0-9979-fd11-f2ee-c0339ba76aab}">
+        <p14:section name="Closing" id="{a8b7c5d5-0956-a2ae-4506-b074b49433de}">
           <p14:sldIdLst>
             <p14:sldId id="268"/>
           </p14:sldIdLst>
@@ -2460,7 +2460,7 @@
       <p:sp>
         <p:nvSpPr>
           <p:cNvPr id="1007" name="login badge 5"/>
-          <p:cNvSpPr/>
+          <p:cNvSpPr txBox="1"/>
           <p:nvPr/>
         </p:nvSpPr>
         <p:spPr>
@@ -2468,13 +2468,11 @@
             <a:off x="5806440" y="2080260"/>
             <a:ext cx="1051560" cy="1097280"/>
           </a:xfrm>
-          <a:prstGeom prst="roundRect">
-            <a:avLst>
-              <a:gd name="adj" fmla="val 13043"/>
-            </a:avLst>
+          <a:prstGeom prst="rect">
+            <a:avLst/>
           </a:prstGeom>
           <a:solidFill>
-            <a:schemeClr val="accent1"/>
+            <a:srgbClr val="E8541E"/>
           </a:solidFill>
           <a:ln/>
         </p:spPr>
@@ -2633,7 +2631,7 @@
       <p:sp>
         <p:nvSpPr>
           <p:cNvPr id="1013" name="app Wallet 10"/>
-          <p:cNvSpPr/>
+          <p:cNvSpPr txBox="1"/>
           <p:nvPr/>
         </p:nvSpPr>
         <p:spPr>
@@ -2641,13 +2639,11 @@
             <a:off x="7543800" y="1234440"/>
             <a:ext cx="1143000" cy="685800"/>
           </a:xfrm>
-          <a:prstGeom prst="roundRect">
-            <a:avLst>
-              <a:gd name="adj" fmla="val 20000"/>
-            </a:avLst>
+          <a:prstGeom prst="rect">
+            <a:avLst/>
           </a:prstGeom>
           <a:solidFill>
-            <a:schemeClr val="accent2"/>
+            <a:srgbClr val="1F5FA8"/>
           </a:solidFill>
           <a:ln/>
         </p:spPr>
@@ -2694,7 +2690,7 @@
       <p:sp>
         <p:nvSpPr>
           <p:cNvPr id="1015" name="app Health 12"/>
-          <p:cNvSpPr/>
+          <p:cNvSpPr txBox="1"/>
           <p:nvPr/>
         </p:nvSpPr>
         <p:spPr>
@@ -2702,13 +2698,11 @@
             <a:off x="7543800" y="2286000"/>
             <a:ext cx="1143000" cy="685800"/>
           </a:xfrm>
-          <a:prstGeom prst="roundRect">
-            <a:avLst>
-              <a:gd name="adj" fmla="val 20000"/>
-            </a:avLst>
+          <a:prstGeom prst="rect">
+            <a:avLst/>
           </a:prstGeom>
           <a:solidFill>
-            <a:schemeClr val="accent3"/>
+            <a:srgbClr val="2E7D32"/>
           </a:solidFill>
           <a:ln/>
         </p:spPr>
@@ -2755,7 +2749,7 @@
       <p:sp>
         <p:nvSpPr>
           <p:cNvPr id="1017" name="app Tax 14"/>
-          <p:cNvSpPr/>
+          <p:cNvSpPr txBox="1"/>
           <p:nvPr/>
         </p:nvSpPr>
         <p:spPr>
@@ -2763,13 +2757,11 @@
             <a:off x="7543800" y="3337560"/>
             <a:ext cx="1143000" cy="685800"/>
           </a:xfrm>
-          <a:prstGeom prst="roundRect">
-            <a:avLst>
-              <a:gd name="adj" fmla="val 20000"/>
-            </a:avLst>
+          <a:prstGeom prst="rect">
+            <a:avLst/>
           </a:prstGeom>
           <a:solidFill>
-            <a:schemeClr val="accent4"/>
+            <a:srgbClr val="3E4C66"/>
           </a:solidFill>
           <a:ln/>
         </p:spPr>
@@ -2882,7 +2874,7 @@
       <p:sp>
         <p:nvSpPr>
           <p:cNvPr id="10003" name="card 256"/>
-          <p:cNvSpPr/>
+          <p:cNvSpPr txBox="1"/>
           <p:nvPr/>
         </p:nvSpPr>
         <p:spPr>
@@ -2890,17 +2882,15 @@
             <a:off x="457200" y="1051560"/>
             <a:ext cx="3977640" cy="1039368"/>
           </a:xfrm>
-          <a:prstGeom prst="roundRect">
-            <a:avLst>
-              <a:gd name="adj" fmla="val 7038"/>
-            </a:avLst>
+          <a:prstGeom prst="rect">
+            <a:avLst/>
           </a:prstGeom>
           <a:solidFill>
-            <a:schemeClr val="bg2"/>
+            <a:srgbClr val="F3F5F9"/>
           </a:solidFill>
           <a:ln w="9525">
             <a:solidFill>
-              <a:schemeClr val="accent5"/>
+              <a:srgbClr val="C9D3E3"/>
             </a:solidFill>
             <a:prstDash val="solid"/>
           </a:ln>
@@ -3038,7 +3028,7 @@
       <p:sp>
         <p:nvSpPr>
           <p:cNvPr id="10007" name="card 260"/>
-          <p:cNvSpPr/>
+          <p:cNvSpPr txBox="1"/>
           <p:nvPr/>
         </p:nvSpPr>
         <p:spPr>
@@ -3046,17 +3036,15 @@
             <a:off x="4709160" y="1051560"/>
             <a:ext cx="3977640" cy="1039368"/>
           </a:xfrm>
-          <a:prstGeom prst="roundRect">
-            <a:avLst>
-              <a:gd name="adj" fmla="val 7038"/>
-            </a:avLst>
+          <a:prstGeom prst="rect">
+            <a:avLst/>
           </a:prstGeom>
           <a:solidFill>
-            <a:schemeClr val="bg2"/>
+            <a:srgbClr val="F3F5F9"/>
           </a:solidFill>
           <a:ln w="9525">
             <a:solidFill>
-              <a:schemeClr val="accent5"/>
+              <a:srgbClr val="C9D3E3"/>
             </a:solidFill>
             <a:prstDash val="solid"/>
           </a:ln>
@@ -3194,7 +3182,7 @@
       <p:sp>
         <p:nvSpPr>
           <p:cNvPr id="10011" name="card 264"/>
-          <p:cNvSpPr/>
+          <p:cNvSpPr txBox="1"/>
           <p:nvPr/>
         </p:nvSpPr>
         <p:spPr>
@@ -3202,17 +3190,15 @@
             <a:off x="457200" y="2365248"/>
             <a:ext cx="3977640" cy="1039368"/>
           </a:xfrm>
-          <a:prstGeom prst="roundRect">
-            <a:avLst>
-              <a:gd name="adj" fmla="val 7038"/>
-            </a:avLst>
+          <a:prstGeom prst="rect">
+            <a:avLst/>
           </a:prstGeom>
           <a:solidFill>
-            <a:schemeClr val="bg2"/>
+            <a:srgbClr val="F3F5F9"/>
           </a:solidFill>
           <a:ln w="9525">
             <a:solidFill>
-              <a:schemeClr val="accent5"/>
+              <a:srgbClr val="C9D3E3"/>
             </a:solidFill>
             <a:prstDash val="solid"/>
           </a:ln>
@@ -3350,7 +3336,7 @@
       <p:sp>
         <p:nvSpPr>
           <p:cNvPr id="10015" name="card 268"/>
-          <p:cNvSpPr/>
+          <p:cNvSpPr txBox="1"/>
           <p:nvPr/>
         </p:nvSpPr>
         <p:spPr>
@@ -3358,17 +3344,15 @@
             <a:off x="4709160" y="2365248"/>
             <a:ext cx="3977640" cy="1039368"/>
           </a:xfrm>
-          <a:prstGeom prst="roundRect">
-            <a:avLst>
-              <a:gd name="adj" fmla="val 7038"/>
-            </a:avLst>
+          <a:prstGeom prst="rect">
+            <a:avLst/>
           </a:prstGeom>
           <a:solidFill>
-            <a:schemeClr val="bg2"/>
+            <a:srgbClr val="F3F5F9"/>
           </a:solidFill>
           <a:ln w="9525">
             <a:solidFill>
-              <a:schemeClr val="accent5"/>
+              <a:srgbClr val="C9D3E3"/>
             </a:solidFill>
             <a:prstDash val="solid"/>
           </a:ln>
@@ -3506,7 +3490,7 @@
       <p:sp>
         <p:nvSpPr>
           <p:cNvPr id="10019" name="also bar 272"/>
-          <p:cNvSpPr/>
+          <p:cNvSpPr txBox="1"/>
           <p:nvPr/>
         </p:nvSpPr>
         <p:spPr>
@@ -3514,13 +3498,11 @@
             <a:off x="457200" y="3678936"/>
             <a:ext cx="8229600" cy="676656"/>
           </a:xfrm>
-          <a:prstGeom prst="roundRect">
-            <a:avLst>
-              <a:gd name="adj" fmla="val 10811"/>
-            </a:avLst>
+          <a:prstGeom prst="rect">
+            <a:avLst/>
           </a:prstGeom>
           <a:solidFill>
-            <a:schemeClr val="accent6"/>
+            <a:srgbClr val="FFE6D9"/>
           </a:solidFill>
           <a:ln/>
         </p:spPr>
@@ -3693,7 +3675,7 @@
       <p:sp>
         <p:nvSpPr>
           <p:cNvPr id="11003" name="phone frame 274"/>
-          <p:cNvSpPr/>
+          <p:cNvSpPr txBox="1"/>
           <p:nvPr/>
         </p:nvSpPr>
         <p:spPr>
@@ -3701,13 +3683,11 @@
             <a:off x="457200" y="1371600"/>
             <a:ext cx="1822975" cy="2834640"/>
           </a:xfrm>
-          <a:prstGeom prst="roundRect">
-            <a:avLst>
-              <a:gd name="adj" fmla="val 6019"/>
-            </a:avLst>
+          <a:prstGeom prst="rect">
+            <a:avLst/>
           </a:prstGeom>
           <a:solidFill>
-            <a:schemeClr val="tx1"/>
+            <a:srgbClr val="1B2535"/>
           </a:solidFill>
           <a:ln/>
         </p:spPr>
@@ -3739,7 +3719,7 @@
       <p:sp>
         <p:nvSpPr>
           <p:cNvPr id="11005" name="phone frame 275"/>
-          <p:cNvSpPr/>
+          <p:cNvSpPr txBox="1"/>
           <p:nvPr/>
         </p:nvSpPr>
         <p:spPr>
@@ -3747,13 +3727,11 @@
             <a:off x="2463055" y="1371600"/>
             <a:ext cx="1953575" cy="2834640"/>
           </a:xfrm>
-          <a:prstGeom prst="roundRect">
-            <a:avLst>
-              <a:gd name="adj" fmla="val 5617"/>
-            </a:avLst>
+          <a:prstGeom prst="rect">
+            <a:avLst/>
           </a:prstGeom>
           <a:solidFill>
-            <a:schemeClr val="tx1"/>
+            <a:srgbClr val="1B2535"/>
           </a:solidFill>
           <a:ln/>
         </p:spPr>
@@ -3785,7 +3763,7 @@
       <p:sp>
         <p:nvSpPr>
           <p:cNvPr id="11007" name="marker 276"/>
-          <p:cNvSpPr/>
+          <p:cNvSpPr txBox="1"/>
           <p:nvPr/>
         </p:nvSpPr>
         <p:spPr>
@@ -3793,11 +3771,11 @@
             <a:off x="4782389" y="1353312"/>
             <a:ext cx="91440" cy="91440"/>
           </a:xfrm>
-          <a:prstGeom prst="ellipse">
+          <a:prstGeom prst="rect">
             <a:avLst/>
           </a:prstGeom>
           <a:solidFill>
-            <a:schemeClr val="accent2"/>
+            <a:srgbClr val="1F5FA8"/>
           </a:solidFill>
           <a:ln/>
         </p:spPr>
@@ -3891,7 +3869,7 @@
       <p:sp>
         <p:nvSpPr>
           <p:cNvPr id="11009" name="marker 278"/>
-          <p:cNvSpPr/>
+          <p:cNvSpPr txBox="1"/>
           <p:nvPr/>
         </p:nvSpPr>
         <p:spPr>
@@ -3899,11 +3877,11 @@
             <a:off x="4782389" y="2231136"/>
             <a:ext cx="91440" cy="91440"/>
           </a:xfrm>
-          <a:prstGeom prst="ellipse">
+          <a:prstGeom prst="rect">
             <a:avLst/>
           </a:prstGeom>
           <a:solidFill>
-            <a:schemeClr val="accent2"/>
+            <a:srgbClr val="1F5FA8"/>
           </a:solidFill>
           <a:ln/>
         </p:spPr>
@@ -3985,7 +3963,7 @@
       <p:sp>
         <p:nvSpPr>
           <p:cNvPr id="11011" name="marker 280"/>
-          <p:cNvSpPr/>
+          <p:cNvSpPr txBox="1"/>
           <p:nvPr/>
         </p:nvSpPr>
         <p:spPr>
@@ -3993,11 +3971,11 @@
             <a:off x="4782389" y="2926080"/>
             <a:ext cx="91440" cy="91440"/>
           </a:xfrm>
-          <a:prstGeom prst="ellipse">
+          <a:prstGeom prst="rect">
             <a:avLst/>
           </a:prstGeom>
           <a:solidFill>
-            <a:schemeClr val="accent2"/>
+            <a:srgbClr val="1F5FA8"/>
           </a:solidFill>
           <a:ln/>
         </p:spPr>
@@ -4067,7 +4045,7 @@
       <p:sp>
         <p:nvSpPr>
           <p:cNvPr id="11013" name="marker 282"/>
-          <p:cNvSpPr/>
+          <p:cNvSpPr txBox="1"/>
           <p:nvPr/>
         </p:nvSpPr>
         <p:spPr>
@@ -4075,11 +4053,11 @@
             <a:off x="4782389" y="3438144"/>
             <a:ext cx="91440" cy="91440"/>
           </a:xfrm>
-          <a:prstGeom prst="ellipse">
+          <a:prstGeom prst="rect">
             <a:avLst/>
           </a:prstGeom>
           <a:solidFill>
-            <a:schemeClr val="accent2"/>
+            <a:srgbClr val="1F5FA8"/>
           </a:solidFill>
           <a:ln/>
         </p:spPr>
@@ -4149,7 +4127,7 @@
       <p:sp>
         <p:nvSpPr>
           <p:cNvPr id="11015" name="marker 284"/>
-          <p:cNvSpPr/>
+          <p:cNvSpPr txBox="1"/>
           <p:nvPr/>
         </p:nvSpPr>
         <p:spPr>
@@ -4157,11 +4135,11 @@
             <a:off x="4782389" y="3950208"/>
             <a:ext cx="91440" cy="91440"/>
           </a:xfrm>
-          <a:prstGeom prst="ellipse">
+          <a:prstGeom prst="rect">
             <a:avLst/>
           </a:prstGeom>
           <a:solidFill>
-            <a:schemeClr val="accent2"/>
+            <a:srgbClr val="1F5FA8"/>
           </a:solidFill>
           <a:ln/>
         </p:spPr>
@@ -4345,7 +4323,7 @@
       <p:sp>
         <p:nvSpPr>
           <p:cNvPr id="12003" name="card 286"/>
-          <p:cNvSpPr/>
+          <p:cNvSpPr txBox="1"/>
           <p:nvPr/>
         </p:nvSpPr>
         <p:spPr>
@@ -4353,17 +4331,15 @@
             <a:off x="457200" y="1051560"/>
             <a:ext cx="3977640" cy="3465576"/>
           </a:xfrm>
-          <a:prstGeom prst="roundRect">
-            <a:avLst>
-              <a:gd name="adj" fmla="val 2111"/>
-            </a:avLst>
+          <a:prstGeom prst="rect">
+            <a:avLst/>
           </a:prstGeom>
           <a:solidFill>
-            <a:schemeClr val="bg2"/>
+            <a:srgbClr val="F3F5F9"/>
           </a:solidFill>
           <a:ln w="9525">
             <a:solidFill>
-              <a:schemeClr val="accent5"/>
+              <a:srgbClr val="C9D3E3"/>
             </a:solidFill>
             <a:prstDash val="solid"/>
           </a:ln>
@@ -4411,7 +4387,7 @@
       <p:sp>
         <p:nvSpPr>
           <p:cNvPr id="12005" name="marker 288"/>
-          <p:cNvSpPr/>
+          <p:cNvSpPr txBox="1"/>
           <p:nvPr/>
         </p:nvSpPr>
         <p:spPr>
@@ -4419,11 +4395,11 @@
             <a:off x="685800" y="1783080"/>
             <a:ext cx="91440" cy="91440"/>
           </a:xfrm>
-          <a:prstGeom prst="ellipse">
+          <a:prstGeom prst="rect">
             <a:avLst/>
           </a:prstGeom>
           <a:solidFill>
-            <a:schemeClr val="accent1"/>
+            <a:srgbClr val="E8541E"/>
           </a:solidFill>
           <a:ln/>
         </p:spPr>
@@ -4505,7 +4481,7 @@
       <p:sp>
         <p:nvSpPr>
           <p:cNvPr id="12007" name="marker 290"/>
-          <p:cNvSpPr/>
+          <p:cNvSpPr txBox="1"/>
           <p:nvPr/>
         </p:nvSpPr>
         <p:spPr>
@@ -4513,11 +4489,11 @@
             <a:off x="685800" y="2478024"/>
             <a:ext cx="91440" cy="91440"/>
           </a:xfrm>
-          <a:prstGeom prst="ellipse">
+          <a:prstGeom prst="rect">
             <a:avLst/>
           </a:prstGeom>
           <a:solidFill>
-            <a:schemeClr val="accent1"/>
+            <a:srgbClr val="E8541E"/>
           </a:solidFill>
           <a:ln/>
         </p:spPr>
@@ -4600,7 +4576,7 @@
       <p:sp>
         <p:nvSpPr>
           <p:cNvPr id="12009" name="marker 292"/>
-          <p:cNvSpPr/>
+          <p:cNvSpPr txBox="1"/>
           <p:nvPr/>
         </p:nvSpPr>
         <p:spPr>
@@ -4608,11 +4584,11 @@
             <a:off x="685800" y="3355848"/>
             <a:ext cx="91440" cy="91440"/>
           </a:xfrm>
-          <a:prstGeom prst="ellipse">
+          <a:prstGeom prst="rect">
             <a:avLst/>
           </a:prstGeom>
           <a:solidFill>
-            <a:schemeClr val="accent1"/>
+            <a:srgbClr val="E8541E"/>
           </a:solidFill>
           <a:ln/>
         </p:spPr>
@@ -4682,7 +4658,7 @@
       <p:sp>
         <p:nvSpPr>
           <p:cNvPr id="12011" name="marker 294"/>
-          <p:cNvSpPr/>
+          <p:cNvSpPr txBox="1"/>
           <p:nvPr/>
         </p:nvSpPr>
         <p:spPr>
@@ -4690,11 +4666,11 @@
             <a:off x="685800" y="3867912"/>
             <a:ext cx="91440" cy="91440"/>
           </a:xfrm>
-          <a:prstGeom prst="ellipse">
+          <a:prstGeom prst="rect">
             <a:avLst/>
           </a:prstGeom>
           <a:solidFill>
-            <a:schemeClr val="accent1"/>
+            <a:srgbClr val="E8541E"/>
           </a:solidFill>
           <a:ln/>
         </p:spPr>
@@ -4764,7 +4740,7 @@
       <p:sp>
         <p:nvSpPr>
           <p:cNvPr id="12013" name="card 296"/>
-          <p:cNvSpPr/>
+          <p:cNvSpPr txBox="1"/>
           <p:nvPr/>
         </p:nvSpPr>
         <p:spPr>
@@ -4772,17 +4748,15 @@
             <a:off x="4709160" y="1051560"/>
             <a:ext cx="3977640" cy="3465576"/>
           </a:xfrm>
-          <a:prstGeom prst="roundRect">
-            <a:avLst>
-              <a:gd name="adj" fmla="val 2111"/>
-            </a:avLst>
+          <a:prstGeom prst="rect">
+            <a:avLst/>
           </a:prstGeom>
           <a:solidFill>
-            <a:schemeClr val="bg2"/>
+            <a:srgbClr val="F3F5F9"/>
           </a:solidFill>
           <a:ln w="9525">
             <a:solidFill>
-              <a:schemeClr val="accent5"/>
+              <a:srgbClr val="C9D3E3"/>
             </a:solidFill>
             <a:prstDash val="solid"/>
           </a:ln>
@@ -4830,7 +4804,7 @@
       <p:sp>
         <p:nvSpPr>
           <p:cNvPr id="12015" name="marker 298"/>
-          <p:cNvSpPr/>
+          <p:cNvSpPr txBox="1"/>
           <p:nvPr/>
         </p:nvSpPr>
         <p:spPr>
@@ -4838,11 +4812,11 @@
             <a:off x="4937760" y="1783080"/>
             <a:ext cx="91440" cy="91440"/>
           </a:xfrm>
-          <a:prstGeom prst="ellipse">
+          <a:prstGeom prst="rect">
             <a:avLst/>
           </a:prstGeom>
           <a:solidFill>
-            <a:schemeClr val="accent2"/>
+            <a:srgbClr val="1F5FA8"/>
           </a:solidFill>
           <a:ln/>
         </p:spPr>
@@ -4901,7 +4875,7 @@
       <p:sp>
         <p:nvSpPr>
           <p:cNvPr id="12017" name="marker 300"/>
-          <p:cNvSpPr/>
+          <p:cNvSpPr txBox="1"/>
           <p:nvPr/>
         </p:nvSpPr>
         <p:spPr>
@@ -4909,11 +4883,11 @@
             <a:off x="4937760" y="2295144"/>
             <a:ext cx="91440" cy="91440"/>
           </a:xfrm>
-          <a:prstGeom prst="ellipse">
+          <a:prstGeom prst="rect">
             <a:avLst/>
           </a:prstGeom>
           <a:solidFill>
-            <a:schemeClr val="accent2"/>
+            <a:srgbClr val="1F5FA8"/>
           </a:solidFill>
           <a:ln/>
         </p:spPr>
@@ -4972,7 +4946,7 @@
       <p:sp>
         <p:nvSpPr>
           <p:cNvPr id="12019" name="marker 302"/>
-          <p:cNvSpPr/>
+          <p:cNvSpPr txBox="1"/>
           <p:nvPr/>
         </p:nvSpPr>
         <p:spPr>
@@ -4980,11 +4954,11 @@
             <a:off x="4937760" y="2807208"/>
             <a:ext cx="91440" cy="91440"/>
           </a:xfrm>
-          <a:prstGeom prst="ellipse">
+          <a:prstGeom prst="rect">
             <a:avLst/>
           </a:prstGeom>
           <a:solidFill>
-            <a:schemeClr val="accent2"/>
+            <a:srgbClr val="1F5FA8"/>
           </a:solidFill>
           <a:ln/>
         </p:spPr>
@@ -5043,7 +5017,7 @@
       <p:sp>
         <p:nvSpPr>
           <p:cNvPr id="12021" name="marker 304"/>
-          <p:cNvSpPr/>
+          <p:cNvSpPr txBox="1"/>
           <p:nvPr/>
         </p:nvSpPr>
         <p:spPr>
@@ -5051,11 +5025,11 @@
             <a:off x="4937760" y="3319272"/>
             <a:ext cx="91440" cy="91440"/>
           </a:xfrm>
-          <a:prstGeom prst="ellipse">
+          <a:prstGeom prst="rect">
             <a:avLst/>
           </a:prstGeom>
           <a:solidFill>
-            <a:schemeClr val="accent2"/>
+            <a:srgbClr val="1F5FA8"/>
           </a:solidFill>
           <a:ln/>
         </p:spPr>
@@ -5114,7 +5088,7 @@
       <p:sp>
         <p:nvSpPr>
           <p:cNvPr id="12023" name="marker 306"/>
-          <p:cNvSpPr/>
+          <p:cNvSpPr txBox="1"/>
           <p:nvPr/>
         </p:nvSpPr>
         <p:spPr>
@@ -5122,11 +5096,11 @@
             <a:off x="4937760" y="3831336"/>
             <a:ext cx="91440" cy="91440"/>
           </a:xfrm>
-          <a:prstGeom prst="ellipse">
+          <a:prstGeom prst="rect">
             <a:avLst/>
           </a:prstGeom>
           <a:solidFill>
-            <a:schemeClr val="accent2"/>
+            <a:srgbClr val="1F5FA8"/>
           </a:solidFill>
           <a:ln/>
         </p:spPr>
@@ -5399,7 +5373,7 @@
       <p:sp>
         <p:nvSpPr>
           <p:cNvPr id="13005" name="command panel 310"/>
-          <p:cNvSpPr/>
+          <p:cNvSpPr txBox="1"/>
           <p:nvPr/>
         </p:nvSpPr>
         <p:spPr>
@@ -5407,13 +5381,11 @@
             <a:off x="548640" y="3108960"/>
             <a:ext cx="4754880" cy="1188720"/>
           </a:xfrm>
-          <a:prstGeom prst="roundRect">
-            <a:avLst>
-              <a:gd name="adj" fmla="val 6154"/>
-            </a:avLst>
+          <a:prstGeom prst="rect">
+            <a:avLst/>
           </a:prstGeom>
           <a:solidFill>
-            <a:schemeClr val="accent4"/>
+            <a:srgbClr val="3E4C66"/>
           </a:solidFill>
           <a:ln/>
         </p:spPr>
@@ -5533,7 +5505,7 @@
       <p:sp>
         <p:nvSpPr>
           <p:cNvPr id="13008" name="recap tile 312"/>
-          <p:cNvSpPr/>
+          <p:cNvSpPr txBox="1"/>
           <p:nvPr/>
         </p:nvSpPr>
         <p:spPr>
@@ -5541,13 +5513,11 @@
             <a:off x="5577840" y="3108960"/>
             <a:ext cx="914400" cy="1188720"/>
           </a:xfrm>
-          <a:prstGeom prst="roundRect">
-            <a:avLst>
-              <a:gd name="adj" fmla="val 8000"/>
-            </a:avLst>
+          <a:prstGeom prst="rect">
+            <a:avLst/>
           </a:prstGeom>
           <a:solidFill>
-            <a:schemeClr val="accent4"/>
+            <a:srgbClr val="3E4C66"/>
           </a:solidFill>
           <a:ln/>
         </p:spPr>
@@ -5633,7 +5603,7 @@
       <p:sp>
         <p:nvSpPr>
           <p:cNvPr id="13011" name="recap tile 315"/>
-          <p:cNvSpPr/>
+          <p:cNvSpPr txBox="1"/>
           <p:nvPr/>
         </p:nvSpPr>
         <p:spPr>
@@ -5641,13 +5611,11 @@
             <a:off x="6629400" y="3108960"/>
             <a:ext cx="914400" cy="1188720"/>
           </a:xfrm>
-          <a:prstGeom prst="roundRect">
-            <a:avLst>
-              <a:gd name="adj" fmla="val 8000"/>
-            </a:avLst>
+          <a:prstGeom prst="rect">
+            <a:avLst/>
           </a:prstGeom>
           <a:solidFill>
-            <a:schemeClr val="accent4"/>
+            <a:srgbClr val="3E4C66"/>
           </a:solidFill>
           <a:ln/>
         </p:spPr>
@@ -5733,7 +5701,7 @@
       <p:sp>
         <p:nvSpPr>
           <p:cNvPr id="13014" name="recap tile 318"/>
-          <p:cNvSpPr/>
+          <p:cNvSpPr txBox="1"/>
           <p:nvPr/>
         </p:nvSpPr>
         <p:spPr>
@@ -5741,13 +5709,11 @@
             <a:off x="7680960" y="3108960"/>
             <a:ext cx="914400" cy="1188720"/>
           </a:xfrm>
-          <a:prstGeom prst="roundRect">
-            <a:avLst>
-              <a:gd name="adj" fmla="val 8000"/>
-            </a:avLst>
+          <a:prstGeom prst="rect">
+            <a:avLst/>
           </a:prstGeom>
           <a:solidFill>
-            <a:schemeClr val="accent4"/>
+            <a:srgbClr val="3E4C66"/>
           </a:solidFill>
           <a:ln/>
         </p:spPr>
@@ -6025,7 +5991,7 @@
       <p:sp>
         <p:nvSpPr>
           <p:cNvPr id="2004" name="card 17"/>
-          <p:cNvSpPr/>
+          <p:cNvSpPr txBox="1"/>
           <p:nvPr/>
         </p:nvSpPr>
         <p:spPr>
@@ -6033,17 +5999,15 @@
             <a:off x="457200" y="2392680"/>
             <a:ext cx="1463040" cy="2118360"/>
           </a:xfrm>
-          <a:prstGeom prst="roundRect">
-            <a:avLst>
-              <a:gd name="adj" fmla="val 5000"/>
-            </a:avLst>
+          <a:prstGeom prst="rect">
+            <a:avLst/>
           </a:prstGeom>
           <a:solidFill>
-            <a:schemeClr val="bg2"/>
+            <a:srgbClr val="F3F5F9"/>
           </a:solidFill>
           <a:ln w="9525">
             <a:solidFill>
-              <a:schemeClr val="accent5"/>
+              <a:srgbClr val="C9D3E3"/>
             </a:solidFill>
             <a:prstDash val="solid"/>
           </a:ln>
@@ -6166,7 +6130,7 @@
       <p:sp>
         <p:nvSpPr>
           <p:cNvPr id="2007" name="card 20"/>
-          <p:cNvSpPr/>
+          <p:cNvSpPr txBox="1"/>
           <p:nvPr/>
         </p:nvSpPr>
         <p:spPr>
@@ -6174,17 +6138,15 @@
             <a:off x="2194560" y="2392680"/>
             <a:ext cx="1463040" cy="2118360"/>
           </a:xfrm>
-          <a:prstGeom prst="roundRect">
-            <a:avLst>
-              <a:gd name="adj" fmla="val 5000"/>
-            </a:avLst>
+          <a:prstGeom prst="rect">
+            <a:avLst/>
           </a:prstGeom>
           <a:solidFill>
-            <a:schemeClr val="bg2"/>
+            <a:srgbClr val="F3F5F9"/>
           </a:solidFill>
           <a:ln w="9525">
             <a:solidFill>
-              <a:schemeClr val="accent5"/>
+              <a:srgbClr val="C9D3E3"/>
             </a:solidFill>
             <a:prstDash val="solid"/>
           </a:ln>
@@ -6307,7 +6269,7 @@
       <p:sp>
         <p:nvSpPr>
           <p:cNvPr id="2010" name="card 23"/>
-          <p:cNvSpPr/>
+          <p:cNvSpPr txBox="1"/>
           <p:nvPr/>
         </p:nvSpPr>
         <p:spPr>
@@ -6315,17 +6277,15 @@
             <a:off x="3931920" y="2392680"/>
             <a:ext cx="1463040" cy="2118360"/>
           </a:xfrm>
-          <a:prstGeom prst="roundRect">
-            <a:avLst>
-              <a:gd name="adj" fmla="val 5000"/>
-            </a:avLst>
+          <a:prstGeom prst="rect">
+            <a:avLst/>
           </a:prstGeom>
           <a:solidFill>
-            <a:schemeClr val="bg2"/>
+            <a:srgbClr val="F3F5F9"/>
           </a:solidFill>
           <a:ln w="9525">
             <a:solidFill>
-              <a:schemeClr val="accent5"/>
+              <a:srgbClr val="C9D3E3"/>
             </a:solidFill>
             <a:prstDash val="solid"/>
           </a:ln>
@@ -6424,7 +6384,7 @@
       <p:sp>
         <p:nvSpPr>
           <p:cNvPr id="2013" name="spec panel 26"/>
-          <p:cNvSpPr/>
+          <p:cNvSpPr txBox="1"/>
           <p:nvPr/>
         </p:nvSpPr>
         <p:spPr>
@@ -6432,13 +6392,11 @@
             <a:off x="5669280" y="1051560"/>
             <a:ext cx="3017520" cy="3459480"/>
           </a:xfrm>
-          <a:prstGeom prst="roundRect">
-            <a:avLst>
-              <a:gd name="adj" fmla="val 2424"/>
-            </a:avLst>
+          <a:prstGeom prst="rect">
+            <a:avLst/>
           </a:prstGeom>
           <a:solidFill>
-            <a:schemeClr val="tx1"/>
+            <a:srgbClr val="1B2535"/>
           </a:solidFill>
           <a:ln/>
         </p:spPr>
@@ -6485,7 +6443,7 @@
       <p:sp>
         <p:nvSpPr>
           <p:cNvPr id="2015" name="marker 28"/>
-          <p:cNvSpPr/>
+          <p:cNvSpPr txBox="1"/>
           <p:nvPr/>
         </p:nvSpPr>
         <p:spPr>
@@ -6493,11 +6451,11 @@
             <a:off x="5943600" y="1976628"/>
             <a:ext cx="91440" cy="91440"/>
           </a:xfrm>
-          <a:prstGeom prst="ellipse">
+          <a:prstGeom prst="rect">
             <a:avLst/>
           </a:prstGeom>
           <a:solidFill>
-            <a:schemeClr val="accent1"/>
+            <a:srgbClr val="E8541E"/>
           </a:solidFill>
           <a:ln/>
         </p:spPr>
@@ -6580,7 +6538,7 @@
       <p:sp>
         <p:nvSpPr>
           <p:cNvPr id="2017" name="marker 30"/>
-          <p:cNvSpPr/>
+          <p:cNvSpPr txBox="1"/>
           <p:nvPr/>
         </p:nvSpPr>
         <p:spPr>
@@ -6588,11 +6546,11 @@
             <a:off x="5943600" y="2872740"/>
             <a:ext cx="91440" cy="91440"/>
           </a:xfrm>
-          <a:prstGeom prst="ellipse">
+          <a:prstGeom prst="rect">
             <a:avLst/>
           </a:prstGeom>
           <a:solidFill>
-            <a:schemeClr val="accent1"/>
+            <a:srgbClr val="E8541E"/>
           </a:solidFill>
           <a:ln/>
         </p:spPr>
@@ -6663,7 +6621,7 @@
       <p:sp>
         <p:nvSpPr>
           <p:cNvPr id="2019" name="marker 32"/>
-          <p:cNvSpPr/>
+          <p:cNvSpPr txBox="1"/>
           <p:nvPr/>
         </p:nvSpPr>
         <p:spPr>
@@ -6671,11 +6629,11 @@
             <a:off x="5943600" y="3585972"/>
             <a:ext cx="91440" cy="91440"/>
           </a:xfrm>
-          <a:prstGeom prst="ellipse">
+          <a:prstGeom prst="rect">
             <a:avLst/>
           </a:prstGeom>
           <a:solidFill>
-            <a:schemeClr val="accent1"/>
+            <a:srgbClr val="E8541E"/>
           </a:solidFill>
           <a:ln/>
         </p:spPr>
@@ -6860,7 +6818,7 @@
       <p:sp>
         <p:nvSpPr>
           <p:cNvPr id="3003" name="card 34"/>
-          <p:cNvSpPr/>
+          <p:cNvSpPr txBox="1"/>
           <p:nvPr/>
         </p:nvSpPr>
         <p:spPr>
@@ -6868,17 +6826,15 @@
             <a:off x="457200" y="1051560"/>
             <a:ext cx="2560320" cy="2441448"/>
           </a:xfrm>
-          <a:prstGeom prst="roundRect">
-            <a:avLst>
-              <a:gd name="adj" fmla="val 2996"/>
-            </a:avLst>
+          <a:prstGeom prst="rect">
+            <a:avLst/>
           </a:prstGeom>
           <a:solidFill>
-            <a:schemeClr val="bg2"/>
+            <a:srgbClr val="F3F5F9"/>
           </a:solidFill>
           <a:ln w="9525">
             <a:solidFill>
-              <a:schemeClr val="accent5"/>
+              <a:srgbClr val="C9D3E3"/>
             </a:solidFill>
             <a:prstDash val="solid"/>
           </a:ln>
@@ -6887,7 +6843,7 @@
       <p:sp>
         <p:nvSpPr>
           <p:cNvPr id="3004" name="badge 35"/>
-          <p:cNvSpPr/>
+          <p:cNvSpPr txBox="1"/>
           <p:nvPr/>
         </p:nvSpPr>
         <p:spPr>
@@ -6895,11 +6851,11 @@
             <a:off x="685800" y="1280160"/>
             <a:ext cx="365760" cy="365760"/>
           </a:xfrm>
-          <a:prstGeom prst="ellipse">
+          <a:prstGeom prst="rect">
             <a:avLst/>
           </a:prstGeom>
           <a:solidFill>
-            <a:schemeClr val="accent2"/>
+            <a:srgbClr val="1F5FA8"/>
           </a:solidFill>
           <a:ln/>
         </p:spPr>
@@ -7123,7 +7079,7 @@
       <p:sp>
         <p:nvSpPr>
           <p:cNvPr id="3009" name="card 40"/>
-          <p:cNvSpPr/>
+          <p:cNvSpPr txBox="1"/>
           <p:nvPr/>
         </p:nvSpPr>
         <p:spPr>
@@ -7131,17 +7087,15 @@
             <a:off x="3291840" y="1051560"/>
             <a:ext cx="2560320" cy="2441448"/>
           </a:xfrm>
-          <a:prstGeom prst="roundRect">
-            <a:avLst>
-              <a:gd name="adj" fmla="val 2996"/>
-            </a:avLst>
+          <a:prstGeom prst="rect">
+            <a:avLst/>
           </a:prstGeom>
           <a:solidFill>
-            <a:schemeClr val="bg2"/>
+            <a:srgbClr val="F3F5F9"/>
           </a:solidFill>
           <a:ln w="9525">
             <a:solidFill>
-              <a:schemeClr val="accent5"/>
+              <a:srgbClr val="C9D3E3"/>
             </a:solidFill>
             <a:prstDash val="solid"/>
           </a:ln>
@@ -7150,7 +7104,7 @@
       <p:sp>
         <p:nvSpPr>
           <p:cNvPr id="3010" name="badge 41"/>
-          <p:cNvSpPr/>
+          <p:cNvSpPr txBox="1"/>
           <p:nvPr/>
         </p:nvSpPr>
         <p:spPr>
@@ -7158,11 +7112,11 @@
             <a:off x="3520440" y="1280160"/>
             <a:ext cx="365760" cy="365760"/>
           </a:xfrm>
-          <a:prstGeom prst="ellipse">
+          <a:prstGeom prst="rect">
             <a:avLst/>
           </a:prstGeom>
           <a:solidFill>
-            <a:schemeClr val="accent1"/>
+            <a:srgbClr val="E8541E"/>
           </a:solidFill>
           <a:ln/>
         </p:spPr>
@@ -7374,7 +7328,7 @@
       <p:sp>
         <p:nvSpPr>
           <p:cNvPr id="3015" name="card 46"/>
-          <p:cNvSpPr/>
+          <p:cNvSpPr txBox="1"/>
           <p:nvPr/>
         </p:nvSpPr>
         <p:spPr>
@@ -7382,17 +7336,15 @@
             <a:off x="6126480" y="1051560"/>
             <a:ext cx="2560320" cy="2441448"/>
           </a:xfrm>
-          <a:prstGeom prst="roundRect">
-            <a:avLst>
-              <a:gd name="adj" fmla="val 2996"/>
-            </a:avLst>
+          <a:prstGeom prst="rect">
+            <a:avLst/>
           </a:prstGeom>
           <a:solidFill>
-            <a:schemeClr val="bg2"/>
+            <a:srgbClr val="F3F5F9"/>
           </a:solidFill>
           <a:ln w="9525">
             <a:solidFill>
-              <a:schemeClr val="accent5"/>
+              <a:srgbClr val="C9D3E3"/>
             </a:solidFill>
             <a:prstDash val="solid"/>
           </a:ln>
@@ -7401,7 +7353,7 @@
       <p:sp>
         <p:nvSpPr>
           <p:cNvPr id="3016" name="badge 47"/>
-          <p:cNvSpPr/>
+          <p:cNvSpPr txBox="1"/>
           <p:nvPr/>
         </p:nvSpPr>
         <p:spPr>
@@ -7409,11 +7361,11 @@
             <a:off x="6355080" y="1280160"/>
             <a:ext cx="365760" cy="365760"/>
           </a:xfrm>
-          <a:prstGeom prst="ellipse">
+          <a:prstGeom prst="rect">
             <a:avLst/>
           </a:prstGeom>
           <a:solidFill>
-            <a:schemeClr val="accent3"/>
+            <a:srgbClr val="2E7D32"/>
           </a:solidFill>
           <a:ln/>
         </p:spPr>
@@ -7637,7 +7589,7 @@
       <p:sp>
         <p:nvSpPr>
           <p:cNvPr id="3021" name="result bar 52"/>
-          <p:cNvSpPr/>
+          <p:cNvSpPr txBox="1"/>
           <p:nvPr/>
         </p:nvSpPr>
         <p:spPr>
@@ -7645,13 +7597,11 @@
             <a:off x="457200" y="3767328"/>
             <a:ext cx="8229600" cy="725424"/>
           </a:xfrm>
-          <a:prstGeom prst="roundRect">
-            <a:avLst>
-              <a:gd name="adj" fmla="val 10084"/>
-            </a:avLst>
+          <a:prstGeom prst="rect">
+            <a:avLst/>
           </a:prstGeom>
           <a:solidFill>
-            <a:schemeClr val="accent6"/>
+            <a:srgbClr val="FFE6D9"/>
           </a:solidFill>
           <a:ln/>
         </p:spPr>
@@ -7824,7 +7774,7 @@
       <p:sp>
         <p:nvSpPr>
           <p:cNvPr id="4003" name="phone group 54"/>
-          <p:cNvSpPr/>
+          <p:cNvSpPr txBox="1"/>
           <p:nvPr/>
         </p:nvSpPr>
         <p:spPr>
@@ -7832,17 +7782,15 @@
             <a:off x="457200" y="1051560"/>
             <a:ext cx="1965960" cy="3474720"/>
           </a:xfrm>
-          <a:prstGeom prst="roundRect">
-            <a:avLst>
-              <a:gd name="adj" fmla="val 3721"/>
-            </a:avLst>
+          <a:prstGeom prst="rect">
+            <a:avLst/>
           </a:prstGeom>
           <a:solidFill>
-            <a:schemeClr val="bg2"/>
+            <a:srgbClr val="F3F5F9"/>
           </a:solidFill>
           <a:ln w="9525">
             <a:solidFill>
-              <a:schemeClr val="accent5"/>
+              <a:srgbClr val="C9D3E3"/>
             </a:solidFill>
             <a:prstDash val="solid"/>
           </a:ln>
@@ -7851,7 +7799,7 @@
       <p:sp>
         <p:nvSpPr>
           <p:cNvPr id="4004" name="server group 55"/>
-          <p:cNvSpPr/>
+          <p:cNvSpPr txBox="1"/>
           <p:nvPr/>
         </p:nvSpPr>
         <p:spPr>
@@ -7859,17 +7807,15 @@
             <a:off x="3017520" y="1051560"/>
             <a:ext cx="5669280" cy="3474720"/>
           </a:xfrm>
-          <a:prstGeom prst="roundRect">
-            <a:avLst>
-              <a:gd name="adj" fmla="val 2105"/>
-            </a:avLst>
+          <a:prstGeom prst="rect">
+            <a:avLst/>
           </a:prstGeom>
           <a:solidFill>
-            <a:schemeClr val="bg2"/>
+            <a:srgbClr val="F3F5F9"/>
           </a:solidFill>
           <a:ln w="9525">
             <a:solidFill>
-              <a:schemeClr val="accent5"/>
+              <a:srgbClr val="C9D3E3"/>
             </a:solidFill>
             <a:prstDash val="solid"/>
           </a:ln>
@@ -7956,7 +7902,7 @@
       <p:sp>
         <p:nvSpPr>
           <p:cNvPr id="4007" name="box 58"/>
-          <p:cNvSpPr/>
+          <p:cNvSpPr txBox="1"/>
           <p:nvPr/>
         </p:nvSpPr>
         <p:spPr>
@@ -7964,13 +7910,11 @@
             <a:off x="594360" y="1508760"/>
             <a:ext cx="1691640" cy="822960"/>
           </a:xfrm>
-          <a:prstGeom prst="roundRect">
-            <a:avLst>
-              <a:gd name="adj" fmla="val 8889"/>
-            </a:avLst>
+          <a:prstGeom prst="rect">
+            <a:avLst/>
           </a:prstGeom>
           <a:solidFill>
-            <a:schemeClr val="accent2"/>
+            <a:srgbClr val="1F5FA8"/>
           </a:solidFill>
           <a:ln/>
         </p:spPr>
@@ -8034,7 +7978,7 @@
       <p:sp>
         <p:nvSpPr>
           <p:cNvPr id="4009" name="box 60"/>
-          <p:cNvSpPr/>
+          <p:cNvSpPr txBox="1"/>
           <p:nvPr/>
         </p:nvSpPr>
         <p:spPr>
@@ -8042,13 +7986,11 @@
             <a:off x="594360" y="3520440"/>
             <a:ext cx="1691640" cy="822960"/>
           </a:xfrm>
-          <a:prstGeom prst="roundRect">
-            <a:avLst>
-              <a:gd name="adj" fmla="val 8889"/>
-            </a:avLst>
+          <a:prstGeom prst="rect">
+            <a:avLst/>
           </a:prstGeom>
           <a:solidFill>
-            <a:schemeClr val="accent3"/>
+            <a:srgbClr val="2E7D32"/>
           </a:solidFill>
           <a:ln/>
         </p:spPr>
@@ -8249,7 +8191,7 @@
       <p:sp>
         <p:nvSpPr>
           <p:cNvPr id="4014" name="box 65"/>
-          <p:cNvSpPr/>
+          <p:cNvSpPr txBox="1"/>
           <p:nvPr/>
         </p:nvSpPr>
         <p:spPr>
@@ -8257,13 +8199,11 @@
             <a:off x="3246120" y="1508760"/>
             <a:ext cx="1645920" cy="2834640"/>
           </a:xfrm>
-          <a:prstGeom prst="roundRect">
-            <a:avLst>
-              <a:gd name="adj" fmla="val 4444"/>
-            </a:avLst>
+          <a:prstGeom prst="rect">
+            <a:avLst/>
           </a:prstGeom>
           <a:solidFill>
-            <a:schemeClr val="tx1"/>
+            <a:srgbClr val="1B2535"/>
           </a:solidFill>
           <a:ln/>
         </p:spPr>
@@ -8450,7 +8390,7 @@
       <p:sp>
         <p:nvSpPr>
           <p:cNvPr id="4016" name="box 67"/>
-          <p:cNvSpPr/>
+          <p:cNvSpPr txBox="1"/>
           <p:nvPr/>
         </p:nvSpPr>
         <p:spPr>
@@ -8458,13 +8398,11 @@
             <a:off x="5760720" y="1508760"/>
             <a:ext cx="2697480" cy="822960"/>
           </a:xfrm>
-          <a:prstGeom prst="roundRect">
-            <a:avLst>
-              <a:gd name="adj" fmla="val 8889"/>
-            </a:avLst>
+          <a:prstGeom prst="rect">
+            <a:avLst/>
           </a:prstGeom>
           <a:solidFill>
-            <a:schemeClr val="accent1"/>
+            <a:srgbClr val="E8541E"/>
           </a:solidFill>
           <a:ln/>
         </p:spPr>
@@ -8528,7 +8466,7 @@
       <p:sp>
         <p:nvSpPr>
           <p:cNvPr id="4018" name="box 69"/>
-          <p:cNvSpPr/>
+          <p:cNvSpPr txBox="1"/>
           <p:nvPr/>
         </p:nvSpPr>
         <p:spPr>
@@ -8536,13 +8474,11 @@
             <a:off x="5760720" y="3520440"/>
             <a:ext cx="1234440" cy="822960"/>
           </a:xfrm>
-          <a:prstGeom prst="roundRect">
-            <a:avLst>
-              <a:gd name="adj" fmla="val 8889"/>
-            </a:avLst>
+          <a:prstGeom prst="rect">
+            <a:avLst/>
           </a:prstGeom>
           <a:solidFill>
-            <a:schemeClr val="accent4"/>
+            <a:srgbClr val="3E4C66"/>
           </a:solidFill>
           <a:ln/>
         </p:spPr>
@@ -8623,7 +8559,7 @@
       <p:sp>
         <p:nvSpPr>
           <p:cNvPr id="4020" name="box 71"/>
-          <p:cNvSpPr/>
+          <p:cNvSpPr txBox="1"/>
           <p:nvPr/>
         </p:nvSpPr>
         <p:spPr>
@@ -8631,13 +8567,11 @@
             <a:off x="7223760" y="3520440"/>
             <a:ext cx="1234440" cy="822960"/>
           </a:xfrm>
-          <a:prstGeom prst="roundRect">
-            <a:avLst>
-              <a:gd name="adj" fmla="val 8889"/>
-            </a:avLst>
+          <a:prstGeom prst="rect">
+            <a:avLst/>
           </a:prstGeom>
           <a:solidFill>
-            <a:schemeClr val="accent4"/>
+            <a:srgbClr val="3E4C66"/>
           </a:solidFill>
           <a:ln/>
         </p:spPr>
@@ -9244,7 +9178,7 @@
       <p:sp>
         <p:nvSpPr>
           <p:cNvPr id="5003" name="badge 85"/>
-          <p:cNvSpPr/>
+          <p:cNvSpPr txBox="1"/>
           <p:nvPr/>
         </p:nvSpPr>
         <p:spPr>
@@ -9252,11 +9186,11 @@
             <a:off x="457200" y="1051560"/>
             <a:ext cx="365760" cy="365760"/>
           </a:xfrm>
-          <a:prstGeom prst="ellipse">
+          <a:prstGeom prst="rect">
             <a:avLst/>
           </a:prstGeom>
           <a:solidFill>
-            <a:schemeClr val="accent2"/>
+            <a:srgbClr val="1F5FA8"/>
           </a:solidFill>
           <a:ln/>
         </p:spPr>
@@ -9354,7 +9288,7 @@
       <p:sp>
         <p:nvSpPr>
           <p:cNvPr id="5006" name="badge 88"/>
-          <p:cNvSpPr/>
+          <p:cNvSpPr txBox="1"/>
           <p:nvPr/>
         </p:nvSpPr>
         <p:spPr>
@@ -9362,11 +9296,11 @@
             <a:off x="457200" y="1630680"/>
             <a:ext cx="365760" cy="365760"/>
           </a:xfrm>
-          <a:prstGeom prst="ellipse">
+          <a:prstGeom prst="rect">
             <a:avLst/>
           </a:prstGeom>
           <a:solidFill>
-            <a:schemeClr val="accent2"/>
+            <a:srgbClr val="1F5FA8"/>
           </a:solidFill>
           <a:ln/>
         </p:spPr>
@@ -9464,7 +9398,7 @@
       <p:sp>
         <p:nvSpPr>
           <p:cNvPr id="5009" name="badge 91"/>
-          <p:cNvSpPr/>
+          <p:cNvSpPr txBox="1"/>
           <p:nvPr/>
         </p:nvSpPr>
         <p:spPr>
@@ -9472,11 +9406,11 @@
             <a:off x="457200" y="2209800"/>
             <a:ext cx="365760" cy="365760"/>
           </a:xfrm>
-          <a:prstGeom prst="ellipse">
+          <a:prstGeom prst="rect">
             <a:avLst/>
           </a:prstGeom>
           <a:solidFill>
-            <a:schemeClr val="accent2"/>
+            <a:srgbClr val="1F5FA8"/>
           </a:solidFill>
           <a:ln/>
         </p:spPr>
@@ -9574,7 +9508,7 @@
       <p:sp>
         <p:nvSpPr>
           <p:cNvPr id="5012" name="badge 94"/>
-          <p:cNvSpPr/>
+          <p:cNvSpPr txBox="1"/>
           <p:nvPr/>
         </p:nvSpPr>
         <p:spPr>
@@ -9582,11 +9516,11 @@
             <a:off x="457200" y="2788920"/>
             <a:ext cx="365760" cy="365760"/>
           </a:xfrm>
-          <a:prstGeom prst="ellipse">
+          <a:prstGeom prst="rect">
             <a:avLst/>
           </a:prstGeom>
           <a:solidFill>
-            <a:schemeClr val="accent1"/>
+            <a:srgbClr val="E8541E"/>
           </a:solidFill>
           <a:ln/>
         </p:spPr>
@@ -9684,7 +9618,7 @@
       <p:sp>
         <p:nvSpPr>
           <p:cNvPr id="5015" name="badge 97"/>
-          <p:cNvSpPr/>
+          <p:cNvSpPr txBox="1"/>
           <p:nvPr/>
         </p:nvSpPr>
         <p:spPr>
@@ -9692,11 +9626,11 @@
             <a:off x="457200" y="3368040"/>
             <a:ext cx="365760" cy="365760"/>
           </a:xfrm>
-          <a:prstGeom prst="ellipse">
+          <a:prstGeom prst="rect">
             <a:avLst/>
           </a:prstGeom>
           <a:solidFill>
-            <a:schemeClr val="accent1"/>
+            <a:srgbClr val="E8541E"/>
           </a:solidFill>
           <a:ln/>
         </p:spPr>
@@ -9794,7 +9728,7 @@
       <p:sp>
         <p:nvSpPr>
           <p:cNvPr id="5018" name="badge 100"/>
-          <p:cNvSpPr/>
+          <p:cNvSpPr txBox="1"/>
           <p:nvPr/>
         </p:nvSpPr>
         <p:spPr>
@@ -9802,11 +9736,11 @@
             <a:off x="457200" y="3947160"/>
             <a:ext cx="365760" cy="365760"/>
           </a:xfrm>
-          <a:prstGeom prst="ellipse">
+          <a:prstGeom prst="rect">
             <a:avLst/>
           </a:prstGeom>
           <a:solidFill>
-            <a:schemeClr val="accent1"/>
+            <a:srgbClr val="E8541E"/>
           </a:solidFill>
           <a:ln/>
         </p:spPr>
@@ -9904,7 +9838,7 @@
       <p:sp>
         <p:nvSpPr>
           <p:cNvPr id="5021" name="id_token card 103"/>
-          <p:cNvSpPr/>
+          <p:cNvSpPr txBox="1"/>
           <p:nvPr/>
         </p:nvSpPr>
         <p:spPr>
@@ -9912,13 +9846,11 @@
             <a:off x="5486400" y="1051560"/>
             <a:ext cx="3200400" cy="1591056"/>
           </a:xfrm>
-          <a:prstGeom prst="roundRect">
-            <a:avLst>
-              <a:gd name="adj" fmla="val 4598"/>
-            </a:avLst>
+          <a:prstGeom prst="rect">
+            <a:avLst/>
           </a:prstGeom>
           <a:solidFill>
-            <a:schemeClr val="tx1"/>
+            <a:srgbClr val="1B2535"/>
           </a:solidFill>
           <a:ln/>
         </p:spPr>
@@ -10058,7 +9990,7 @@
       <p:sp>
         <p:nvSpPr>
           <p:cNvPr id="5024" name="device secret card 105"/>
-          <p:cNvSpPr/>
+          <p:cNvSpPr txBox="1"/>
           <p:nvPr/>
         </p:nvSpPr>
         <p:spPr>
@@ -10066,13 +9998,11 @@
             <a:off x="5486400" y="2916936"/>
             <a:ext cx="3200400" cy="1609344"/>
           </a:xfrm>
-          <a:prstGeom prst="roundRect">
-            <a:avLst>
-              <a:gd name="adj" fmla="val 4545"/>
-            </a:avLst>
+          <a:prstGeom prst="rect">
+            <a:avLst/>
           </a:prstGeom>
           <a:solidFill>
-            <a:schemeClr val="tx1"/>
+            <a:srgbClr val="1B2535"/>
           </a:solidFill>
           <a:ln/>
         </p:spPr>
@@ -10119,7 +10049,7 @@
       <p:sp>
         <p:nvSpPr>
           <p:cNvPr id="5026" name="claim chip 107"/>
-          <p:cNvSpPr/>
+          <p:cNvSpPr txBox="1"/>
           <p:nvPr/>
         </p:nvSpPr>
         <p:spPr>
@@ -10127,13 +10057,11 @@
             <a:off x="5715000" y="3470148"/>
             <a:ext cx="630936" cy="256032"/>
           </a:xfrm>
-          <a:prstGeom prst="roundRect">
-            <a:avLst>
-              <a:gd name="adj" fmla="val 21429"/>
-            </a:avLst>
+          <a:prstGeom prst="rect">
+            <a:avLst/>
           </a:prstGeom>
           <a:solidFill>
-            <a:schemeClr val="accent4"/>
+            <a:srgbClr val="3E4C66"/>
           </a:solidFill>
           <a:ln/>
         </p:spPr>
@@ -10180,7 +10108,7 @@
       <p:sp>
         <p:nvSpPr>
           <p:cNvPr id="5028" name="claim chip 109"/>
-          <p:cNvSpPr/>
+          <p:cNvSpPr txBox="1"/>
           <p:nvPr/>
         </p:nvSpPr>
         <p:spPr>
@@ -10188,13 +10116,11 @@
             <a:off x="6419088" y="3470148"/>
             <a:ext cx="630936" cy="256032"/>
           </a:xfrm>
-          <a:prstGeom prst="roundRect">
-            <a:avLst>
-              <a:gd name="adj" fmla="val 21429"/>
-            </a:avLst>
+          <a:prstGeom prst="rect">
+            <a:avLst/>
           </a:prstGeom>
           <a:solidFill>
-            <a:schemeClr val="accent4"/>
+            <a:srgbClr val="3E4C66"/>
           </a:solidFill>
           <a:ln/>
         </p:spPr>
@@ -10241,7 +10167,7 @@
       <p:sp>
         <p:nvSpPr>
           <p:cNvPr id="5030" name="claim chip 111"/>
-          <p:cNvSpPr/>
+          <p:cNvSpPr txBox="1"/>
           <p:nvPr/>
         </p:nvSpPr>
         <p:spPr>
@@ -10249,13 +10175,11 @@
             <a:off x="7123176" y="3470148"/>
             <a:ext cx="630936" cy="256032"/>
           </a:xfrm>
-          <a:prstGeom prst="roundRect">
-            <a:avLst>
-              <a:gd name="adj" fmla="val 21429"/>
-            </a:avLst>
+          <a:prstGeom prst="rect">
+            <a:avLst/>
           </a:prstGeom>
           <a:solidFill>
-            <a:schemeClr val="accent4"/>
+            <a:srgbClr val="3E4C66"/>
           </a:solidFill>
           <a:ln/>
         </p:spPr>
@@ -10302,7 +10226,7 @@
       <p:sp>
         <p:nvSpPr>
           <p:cNvPr id="5032" name="claim chip 113"/>
-          <p:cNvSpPr/>
+          <p:cNvSpPr txBox="1"/>
           <p:nvPr/>
         </p:nvSpPr>
         <p:spPr>
@@ -10310,13 +10234,11 @@
             <a:off x="7827264" y="3470148"/>
             <a:ext cx="630936" cy="256032"/>
           </a:xfrm>
-          <a:prstGeom prst="roundRect">
-            <a:avLst>
-              <a:gd name="adj" fmla="val 21429"/>
-            </a:avLst>
+          <a:prstGeom prst="rect">
+            <a:avLst/>
           </a:prstGeom>
           <a:solidFill>
-            <a:schemeClr val="accent4"/>
+            <a:srgbClr val="3E4C66"/>
           </a:solidFill>
           <a:ln/>
         </p:spPr>
@@ -10363,7 +10285,7 @@
       <p:sp>
         <p:nvSpPr>
           <p:cNvPr id="5034" name="claim chip 115"/>
-          <p:cNvSpPr/>
+          <p:cNvSpPr txBox="1"/>
           <p:nvPr/>
         </p:nvSpPr>
         <p:spPr>
@@ -10371,13 +10293,11 @@
             <a:off x="5715000" y="3799332"/>
             <a:ext cx="630936" cy="256032"/>
           </a:xfrm>
-          <a:prstGeom prst="roundRect">
-            <a:avLst>
-              <a:gd name="adj" fmla="val 21429"/>
-            </a:avLst>
+          <a:prstGeom prst="rect">
+            <a:avLst/>
           </a:prstGeom>
           <a:solidFill>
-            <a:schemeClr val="accent4"/>
+            <a:srgbClr val="3E4C66"/>
           </a:solidFill>
           <a:ln/>
         </p:spPr>
@@ -10424,7 +10344,7 @@
       <p:sp>
         <p:nvSpPr>
           <p:cNvPr id="5036" name="claim chip 117"/>
-          <p:cNvSpPr/>
+          <p:cNvSpPr txBox="1"/>
           <p:nvPr/>
         </p:nvSpPr>
         <p:spPr>
@@ -10432,13 +10352,11 @@
             <a:off x="6419088" y="3799332"/>
             <a:ext cx="630936" cy="256032"/>
           </a:xfrm>
-          <a:prstGeom prst="roundRect">
-            <a:avLst>
-              <a:gd name="adj" fmla="val 21429"/>
-            </a:avLst>
+          <a:prstGeom prst="rect">
+            <a:avLst/>
           </a:prstGeom>
           <a:solidFill>
-            <a:schemeClr val="accent4"/>
+            <a:srgbClr val="3E4C66"/>
           </a:solidFill>
           <a:ln/>
         </p:spPr>
@@ -10485,7 +10403,7 @@
       <p:sp>
         <p:nvSpPr>
           <p:cNvPr id="5038" name="claim chip 119"/>
-          <p:cNvSpPr/>
+          <p:cNvSpPr txBox="1"/>
           <p:nvPr/>
         </p:nvSpPr>
         <p:spPr>
@@ -10493,13 +10411,11 @@
             <a:off x="7123176" y="3799332"/>
             <a:ext cx="630936" cy="256032"/>
           </a:xfrm>
-          <a:prstGeom prst="roundRect">
-            <a:avLst>
-              <a:gd name="adj" fmla="val 21429"/>
-            </a:avLst>
+          <a:prstGeom prst="rect">
+            <a:avLst/>
           </a:prstGeom>
           <a:solidFill>
-            <a:schemeClr val="accent4"/>
+            <a:srgbClr val="3E4C66"/>
           </a:solidFill>
           <a:ln/>
         </p:spPr>
@@ -10546,7 +10462,7 @@
       <p:sp>
         <p:nvSpPr>
           <p:cNvPr id="5040" name="claim chip 121"/>
-          <p:cNvSpPr/>
+          <p:cNvSpPr txBox="1"/>
           <p:nvPr/>
         </p:nvSpPr>
         <p:spPr>
@@ -10554,13 +10470,11 @@
             <a:off x="7827264" y="3799332"/>
             <a:ext cx="630936" cy="256032"/>
           </a:xfrm>
-          <a:prstGeom prst="roundRect">
-            <a:avLst>
-              <a:gd name="adj" fmla="val 21429"/>
-            </a:avLst>
+          <a:prstGeom prst="rect">
+            <a:avLst/>
           </a:prstGeom>
           <a:solidFill>
-            <a:schemeClr val="accent4"/>
+            <a:srgbClr val="3E4C66"/>
           </a:solidFill>
           <a:ln/>
         </p:spPr>
@@ -10607,7 +10521,7 @@
       <p:sp>
         <p:nvSpPr>
           <p:cNvPr id="5042" name="claim chip 123"/>
-          <p:cNvSpPr/>
+          <p:cNvSpPr txBox="1"/>
           <p:nvPr/>
         </p:nvSpPr>
         <p:spPr>
@@ -10615,13 +10529,11 @@
             <a:off x="5715000" y="4128516"/>
             <a:ext cx="630936" cy="256032"/>
           </a:xfrm>
-          <a:prstGeom prst="roundRect">
-            <a:avLst>
-              <a:gd name="adj" fmla="val 21429"/>
-            </a:avLst>
+          <a:prstGeom prst="rect">
+            <a:avLst/>
           </a:prstGeom>
           <a:solidFill>
-            <a:schemeClr val="accent4"/>
+            <a:srgbClr val="3E4C66"/>
           </a:solidFill>
           <a:ln/>
         </p:spPr>
@@ -10668,7 +10580,7 @@
       <p:sp>
         <p:nvSpPr>
           <p:cNvPr id="5044" name="claim chip 125"/>
-          <p:cNvSpPr/>
+          <p:cNvSpPr txBox="1"/>
           <p:nvPr/>
         </p:nvSpPr>
         <p:spPr>
@@ -10676,13 +10588,11 @@
             <a:off x="6419088" y="4128516"/>
             <a:ext cx="630936" cy="256032"/>
           </a:xfrm>
-          <a:prstGeom prst="roundRect">
-            <a:avLst>
-              <a:gd name="adj" fmla="val 21429"/>
-            </a:avLst>
+          <a:prstGeom prst="rect">
+            <a:avLst/>
           </a:prstGeom>
           <a:solidFill>
-            <a:schemeClr val="accent4"/>
+            <a:srgbClr val="3E4C66"/>
           </a:solidFill>
           <a:ln/>
         </p:spPr>
@@ -10729,7 +10639,7 @@
       <p:sp>
         <p:nvSpPr>
           <p:cNvPr id="5046" name="claim chip 127"/>
-          <p:cNvSpPr/>
+          <p:cNvSpPr txBox="1"/>
           <p:nvPr/>
         </p:nvSpPr>
         <p:spPr>
@@ -10737,13 +10647,11 @@
             <a:off x="7123176" y="4128516"/>
             <a:ext cx="630936" cy="256032"/>
           </a:xfrm>
-          <a:prstGeom prst="roundRect">
-            <a:avLst>
-              <a:gd name="adj" fmla="val 21429"/>
-            </a:avLst>
+          <a:prstGeom prst="rect">
+            <a:avLst/>
           </a:prstGeom>
           <a:solidFill>
-            <a:schemeClr val="accent4"/>
+            <a:srgbClr val="3E4C66"/>
           </a:solidFill>
           <a:ln/>
         </p:spPr>
@@ -10790,7 +10698,7 @@
       <p:sp>
         <p:nvSpPr>
           <p:cNvPr id="5048" name="claim chip 129"/>
-          <p:cNvSpPr/>
+          <p:cNvSpPr txBox="1"/>
           <p:nvPr/>
         </p:nvSpPr>
         <p:spPr>
@@ -10798,13 +10706,11 @@
             <a:off x="7827264" y="4128516"/>
             <a:ext cx="630936" cy="256032"/>
           </a:xfrm>
-          <a:prstGeom prst="roundRect">
-            <a:avLst>
-              <a:gd name="adj" fmla="val 21429"/>
-            </a:avLst>
+          <a:prstGeom prst="rect">
+            <a:avLst/>
           </a:prstGeom>
           <a:solidFill>
-            <a:schemeClr val="accent4"/>
+            <a:srgbClr val="3E4C66"/>
           </a:solidFill>
           <a:ln/>
         </p:spPr>
@@ -10965,7 +10871,7 @@
       <p:sp>
         <p:nvSpPr>
           <p:cNvPr id="6003" name="badge 131"/>
-          <p:cNvSpPr/>
+          <p:cNvSpPr txBox="1"/>
           <p:nvPr/>
         </p:nvSpPr>
         <p:spPr>
@@ -10973,11 +10879,11 @@
             <a:off x="457200" y="1051560"/>
             <a:ext cx="365760" cy="365760"/>
           </a:xfrm>
-          <a:prstGeom prst="ellipse">
+          <a:prstGeom prst="rect">
             <a:avLst/>
           </a:prstGeom>
           <a:solidFill>
-            <a:schemeClr val="accent3"/>
+            <a:srgbClr val="2E7D32"/>
           </a:solidFill>
           <a:ln/>
         </p:spPr>
@@ -11087,7 +10993,7 @@
       <p:sp>
         <p:nvSpPr>
           <p:cNvPr id="6006" name="badge 134"/>
-          <p:cNvSpPr/>
+          <p:cNvSpPr txBox="1"/>
           <p:nvPr/>
         </p:nvSpPr>
         <p:spPr>
@@ -11095,11 +11001,11 @@
             <a:off x="457200" y="1746504"/>
             <a:ext cx="365760" cy="365760"/>
           </a:xfrm>
-          <a:prstGeom prst="ellipse">
+          <a:prstGeom prst="rect">
             <a:avLst/>
           </a:prstGeom>
           <a:solidFill>
-            <a:schemeClr val="accent3"/>
+            <a:srgbClr val="2E7D32"/>
           </a:solidFill>
           <a:ln/>
         </p:spPr>
@@ -11209,7 +11115,7 @@
       <p:sp>
         <p:nvSpPr>
           <p:cNvPr id="6009" name="badge 137"/>
-          <p:cNvSpPr/>
+          <p:cNvSpPr txBox="1"/>
           <p:nvPr/>
         </p:nvSpPr>
         <p:spPr>
@@ -11217,11 +11123,11 @@
             <a:off x="457200" y="2441448"/>
             <a:ext cx="365760" cy="365760"/>
           </a:xfrm>
-          <a:prstGeom prst="ellipse">
+          <a:prstGeom prst="rect">
             <a:avLst/>
           </a:prstGeom>
           <a:solidFill>
-            <a:schemeClr val="accent2"/>
+            <a:srgbClr val="1F5FA8"/>
           </a:solidFill>
           <a:ln/>
         </p:spPr>
@@ -11331,7 +11237,7 @@
       <p:sp>
         <p:nvSpPr>
           <p:cNvPr id="6012" name="badge 140"/>
-          <p:cNvSpPr/>
+          <p:cNvSpPr txBox="1"/>
           <p:nvPr/>
         </p:nvSpPr>
         <p:spPr>
@@ -11339,11 +11245,11 @@
             <a:off x="457200" y="3136392"/>
             <a:ext cx="365760" cy="365760"/>
           </a:xfrm>
-          <a:prstGeom prst="ellipse">
+          <a:prstGeom prst="rect">
             <a:avLst/>
           </a:prstGeom>
           <a:solidFill>
-            <a:schemeClr val="accent1"/>
+            <a:srgbClr val="E8541E"/>
           </a:solidFill>
           <a:ln/>
         </p:spPr>
@@ -11453,7 +11359,7 @@
       <p:sp>
         <p:nvSpPr>
           <p:cNvPr id="6015" name="badge 143"/>
-          <p:cNvSpPr/>
+          <p:cNvSpPr txBox="1"/>
           <p:nvPr/>
         </p:nvSpPr>
         <p:spPr>
@@ -11461,11 +11367,11 @@
             <a:off x="457200" y="3831336"/>
             <a:ext cx="365760" cy="365760"/>
           </a:xfrm>
-          <a:prstGeom prst="ellipse">
+          <a:prstGeom prst="rect">
             <a:avLst/>
           </a:prstGeom>
           <a:solidFill>
-            <a:schemeClr val="accent1"/>
+            <a:srgbClr val="E8541E"/>
           </a:solidFill>
           <a:ln/>
         </p:spPr>
@@ -11575,7 +11481,7 @@
       <p:sp>
         <p:nvSpPr>
           <p:cNvPr id="6018" name="phone frame 146"/>
-          <p:cNvSpPr/>
+          <p:cNvSpPr txBox="1"/>
           <p:nvPr/>
         </p:nvSpPr>
         <p:spPr>
@@ -11583,13 +11489,11 @@
             <a:off x="4892040" y="1417320"/>
             <a:ext cx="1891503" cy="2743200"/>
           </a:xfrm>
-          <a:prstGeom prst="roundRect">
-            <a:avLst>
-              <a:gd name="adj" fmla="val 5801"/>
-            </a:avLst>
+          <a:prstGeom prst="rect">
+            <a:avLst/>
           </a:prstGeom>
           <a:solidFill>
-            <a:schemeClr val="tx1"/>
+            <a:srgbClr val="1B2535"/>
           </a:solidFill>
           <a:ln/>
         </p:spPr>
@@ -11735,7 +11639,7 @@
       <p:sp>
         <p:nvSpPr>
           <p:cNvPr id="6022" name="token fact 149"/>
-          <p:cNvSpPr/>
+          <p:cNvSpPr txBox="1"/>
           <p:nvPr/>
         </p:nvSpPr>
         <p:spPr>
@@ -11743,17 +11647,15 @@
             <a:off x="7057863" y="2834640"/>
             <a:ext cx="1628937" cy="658368"/>
           </a:xfrm>
-          <a:prstGeom prst="roundRect">
-            <a:avLst>
-              <a:gd name="adj" fmla="val 11111"/>
-            </a:avLst>
+          <a:prstGeom prst="rect">
+            <a:avLst/>
           </a:prstGeom>
           <a:solidFill>
-            <a:schemeClr val="bg2"/>
+            <a:srgbClr val="F3F5F9"/>
           </a:solidFill>
           <a:ln w="9525">
             <a:solidFill>
-              <a:schemeClr val="accent5"/>
+              <a:srgbClr val="C9D3E3"/>
             </a:solidFill>
             <a:prstDash val="solid"/>
           </a:ln>
@@ -11840,7 +11742,7 @@
       <p:sp>
         <p:nvSpPr>
           <p:cNvPr id="6025" name="token fact 152"/>
-          <p:cNvSpPr/>
+          <p:cNvSpPr txBox="1"/>
           <p:nvPr/>
         </p:nvSpPr>
         <p:spPr>
@@ -11848,17 +11750,15 @@
             <a:off x="7057863" y="3675888"/>
             <a:ext cx="1628937" cy="658368"/>
           </a:xfrm>
-          <a:prstGeom prst="roundRect">
-            <a:avLst>
-              <a:gd name="adj" fmla="val 11111"/>
-            </a:avLst>
+          <a:prstGeom prst="rect">
+            <a:avLst/>
           </a:prstGeom>
           <a:solidFill>
-            <a:schemeClr val="bg2"/>
+            <a:srgbClr val="F3F5F9"/>
           </a:solidFill>
           <a:ln w="9525">
             <a:solidFill>
-              <a:schemeClr val="accent5"/>
+              <a:srgbClr val="C9D3E3"/>
             </a:solidFill>
             <a:prstDash val="solid"/>
           </a:ln>
@@ -12059,7 +11959,7 @@
       <p:sp>
         <p:nvSpPr>
           <p:cNvPr id="7003" name="card 155"/>
-          <p:cNvSpPr/>
+          <p:cNvSpPr txBox="1"/>
           <p:nvPr/>
         </p:nvSpPr>
         <p:spPr>
@@ -12067,17 +11967,15 @@
             <a:off x="457200" y="1051560"/>
             <a:ext cx="2560320" cy="1508760"/>
           </a:xfrm>
-          <a:prstGeom prst="roundRect">
-            <a:avLst>
-              <a:gd name="adj" fmla="val 4848"/>
-            </a:avLst>
+          <a:prstGeom prst="rect">
+            <a:avLst/>
           </a:prstGeom>
           <a:solidFill>
-            <a:schemeClr val="bg2"/>
+            <a:srgbClr val="F3F5F9"/>
           </a:solidFill>
           <a:ln w="9525">
             <a:solidFill>
-              <a:schemeClr val="accent5"/>
+              <a:srgbClr val="C9D3E3"/>
             </a:solidFill>
             <a:prstDash val="solid"/>
           </a:ln>
@@ -12086,7 +11984,7 @@
       <p:sp>
         <p:nvSpPr>
           <p:cNvPr id="7004" name="badge 156"/>
-          <p:cNvSpPr/>
+          <p:cNvSpPr txBox="1"/>
           <p:nvPr/>
         </p:nvSpPr>
         <p:spPr>
@@ -12094,11 +11992,11 @@
             <a:off x="685800" y="1280160"/>
             <a:ext cx="365760" cy="365760"/>
           </a:xfrm>
-          <a:prstGeom prst="ellipse">
+          <a:prstGeom prst="rect">
             <a:avLst/>
           </a:prstGeom>
           <a:solidFill>
-            <a:schemeClr val="accent2"/>
+            <a:srgbClr val="1F5FA8"/>
           </a:solidFill>
           <a:ln/>
         </p:spPr>
@@ -12247,7 +12145,7 @@
       <p:sp>
         <p:nvSpPr>
           <p:cNvPr id="7008" name="card 160"/>
-          <p:cNvSpPr/>
+          <p:cNvSpPr txBox="1"/>
           <p:nvPr/>
         </p:nvSpPr>
         <p:spPr>
@@ -12255,17 +12153,15 @@
             <a:off x="3291840" y="1051560"/>
             <a:ext cx="2560320" cy="1508760"/>
           </a:xfrm>
-          <a:prstGeom prst="roundRect">
-            <a:avLst>
-              <a:gd name="adj" fmla="val 4848"/>
-            </a:avLst>
+          <a:prstGeom prst="rect">
+            <a:avLst/>
           </a:prstGeom>
           <a:solidFill>
-            <a:schemeClr val="bg2"/>
+            <a:srgbClr val="F3F5F9"/>
           </a:solidFill>
           <a:ln w="9525">
             <a:solidFill>
-              <a:schemeClr val="accent5"/>
+              <a:srgbClr val="C9D3E3"/>
             </a:solidFill>
             <a:prstDash val="solid"/>
           </a:ln>
@@ -12274,7 +12170,7 @@
       <p:sp>
         <p:nvSpPr>
           <p:cNvPr id="7009" name="badge 161"/>
-          <p:cNvSpPr/>
+          <p:cNvSpPr txBox="1"/>
           <p:nvPr/>
         </p:nvSpPr>
         <p:spPr>
@@ -12282,11 +12178,11 @@
             <a:off x="3520440" y="1280160"/>
             <a:ext cx="365760" cy="365760"/>
           </a:xfrm>
-          <a:prstGeom prst="ellipse">
+          <a:prstGeom prst="rect">
             <a:avLst/>
           </a:prstGeom>
           <a:solidFill>
-            <a:schemeClr val="accent2"/>
+            <a:srgbClr val="1F5FA8"/>
           </a:solidFill>
           <a:ln/>
         </p:spPr>
@@ -12435,7 +12331,7 @@
       <p:sp>
         <p:nvSpPr>
           <p:cNvPr id="7013" name="card 165"/>
-          <p:cNvSpPr/>
+          <p:cNvSpPr txBox="1"/>
           <p:nvPr/>
         </p:nvSpPr>
         <p:spPr>
@@ -12443,17 +12339,15 @@
             <a:off x="6126480" y="1051560"/>
             <a:ext cx="2560320" cy="1508760"/>
           </a:xfrm>
-          <a:prstGeom prst="roundRect">
-            <a:avLst>
-              <a:gd name="adj" fmla="val 4848"/>
-            </a:avLst>
+          <a:prstGeom prst="rect">
+            <a:avLst/>
           </a:prstGeom>
           <a:solidFill>
-            <a:schemeClr val="bg2"/>
+            <a:srgbClr val="F3F5F9"/>
           </a:solidFill>
           <a:ln w="9525">
             <a:solidFill>
-              <a:schemeClr val="accent5"/>
+              <a:srgbClr val="C9D3E3"/>
             </a:solidFill>
             <a:prstDash val="solid"/>
           </a:ln>
@@ -12462,7 +12356,7 @@
       <p:sp>
         <p:nvSpPr>
           <p:cNvPr id="7014" name="badge 166"/>
-          <p:cNvSpPr/>
+          <p:cNvSpPr txBox="1"/>
           <p:nvPr/>
         </p:nvSpPr>
         <p:spPr>
@@ -12470,11 +12364,11 @@
             <a:off x="6355080" y="1280160"/>
             <a:ext cx="365760" cy="365760"/>
           </a:xfrm>
-          <a:prstGeom prst="ellipse">
+          <a:prstGeom prst="rect">
             <a:avLst/>
           </a:prstGeom>
           <a:solidFill>
-            <a:schemeClr val="accent2"/>
+            <a:srgbClr val="1F5FA8"/>
           </a:solidFill>
           <a:ln/>
         </p:spPr>
@@ -12623,7 +12517,7 @@
       <p:sp>
         <p:nvSpPr>
           <p:cNvPr id="7018" name="card 170"/>
-          <p:cNvSpPr/>
+          <p:cNvSpPr txBox="1"/>
           <p:nvPr/>
         </p:nvSpPr>
         <p:spPr>
@@ -12631,17 +12525,15 @@
             <a:off x="457200" y="2834640"/>
             <a:ext cx="2560320" cy="1508760"/>
           </a:xfrm>
-          <a:prstGeom prst="roundRect">
-            <a:avLst>
-              <a:gd name="adj" fmla="val 4848"/>
-            </a:avLst>
+          <a:prstGeom prst="rect">
+            <a:avLst/>
           </a:prstGeom>
           <a:solidFill>
-            <a:schemeClr val="bg2"/>
+            <a:srgbClr val="F3F5F9"/>
           </a:solidFill>
           <a:ln w="9525">
             <a:solidFill>
-              <a:schemeClr val="accent5"/>
+              <a:srgbClr val="C9D3E3"/>
             </a:solidFill>
             <a:prstDash val="solid"/>
           </a:ln>
@@ -12650,7 +12542,7 @@
       <p:sp>
         <p:nvSpPr>
           <p:cNvPr id="7019" name="badge 171"/>
-          <p:cNvSpPr/>
+          <p:cNvSpPr txBox="1"/>
           <p:nvPr/>
         </p:nvSpPr>
         <p:spPr>
@@ -12658,11 +12550,11 @@
             <a:off x="685800" y="3063240"/>
             <a:ext cx="365760" cy="365760"/>
           </a:xfrm>
-          <a:prstGeom prst="ellipse">
+          <a:prstGeom prst="rect">
             <a:avLst/>
           </a:prstGeom>
           <a:solidFill>
-            <a:schemeClr val="accent1"/>
+            <a:srgbClr val="E8541E"/>
           </a:solidFill>
           <a:ln/>
         </p:spPr>
@@ -12811,7 +12703,7 @@
       <p:sp>
         <p:nvSpPr>
           <p:cNvPr id="7023" name="card 175"/>
-          <p:cNvSpPr/>
+          <p:cNvSpPr txBox="1"/>
           <p:nvPr/>
         </p:nvSpPr>
         <p:spPr>
@@ -12819,17 +12711,15 @@
             <a:off x="3291840" y="2834640"/>
             <a:ext cx="2560320" cy="1508760"/>
           </a:xfrm>
-          <a:prstGeom prst="roundRect">
-            <a:avLst>
-              <a:gd name="adj" fmla="val 4848"/>
-            </a:avLst>
+          <a:prstGeom prst="rect">
+            <a:avLst/>
           </a:prstGeom>
           <a:solidFill>
-            <a:schemeClr val="bg2"/>
+            <a:srgbClr val="F3F5F9"/>
           </a:solidFill>
           <a:ln w="9525">
             <a:solidFill>
-              <a:schemeClr val="accent5"/>
+              <a:srgbClr val="C9D3E3"/>
             </a:solidFill>
             <a:prstDash val="solid"/>
           </a:ln>
@@ -12838,7 +12728,7 @@
       <p:sp>
         <p:nvSpPr>
           <p:cNvPr id="7024" name="badge 176"/>
-          <p:cNvSpPr/>
+          <p:cNvSpPr txBox="1"/>
           <p:nvPr/>
         </p:nvSpPr>
         <p:spPr>
@@ -12846,11 +12736,11 @@
             <a:off x="3520440" y="3063240"/>
             <a:ext cx="365760" cy="365760"/>
           </a:xfrm>
-          <a:prstGeom prst="ellipse">
+          <a:prstGeom prst="rect">
             <a:avLst/>
           </a:prstGeom>
           <a:solidFill>
-            <a:schemeClr val="accent1"/>
+            <a:srgbClr val="E8541E"/>
           </a:solidFill>
           <a:ln/>
         </p:spPr>
@@ -12999,7 +12889,7 @@
       <p:sp>
         <p:nvSpPr>
           <p:cNvPr id="7028" name="card 180"/>
-          <p:cNvSpPr/>
+          <p:cNvSpPr txBox="1"/>
           <p:nvPr/>
         </p:nvSpPr>
         <p:spPr>
@@ -13007,17 +12897,15 @@
             <a:off x="6126480" y="2834640"/>
             <a:ext cx="2560320" cy="1508760"/>
           </a:xfrm>
-          <a:prstGeom prst="roundRect">
-            <a:avLst>
-              <a:gd name="adj" fmla="val 4848"/>
-            </a:avLst>
+          <a:prstGeom prst="rect">
+            <a:avLst/>
           </a:prstGeom>
           <a:solidFill>
-            <a:schemeClr val="bg2"/>
+            <a:srgbClr val="F3F5F9"/>
           </a:solidFill>
           <a:ln w="9525">
             <a:solidFill>
-              <a:schemeClr val="accent5"/>
+              <a:srgbClr val="C9D3E3"/>
             </a:solidFill>
             <a:prstDash val="solid"/>
           </a:ln>
@@ -13026,7 +12914,7 @@
       <p:sp>
         <p:nvSpPr>
           <p:cNvPr id="7029" name="badge 181"/>
-          <p:cNvSpPr/>
+          <p:cNvSpPr txBox="1"/>
           <p:nvPr/>
         </p:nvSpPr>
         <p:spPr>
@@ -13034,11 +12922,11 @@
             <a:off x="6355080" y="3063240"/>
             <a:ext cx="365760" cy="365760"/>
           </a:xfrm>
-          <a:prstGeom prst="ellipse">
+          <a:prstGeom prst="rect">
             <a:avLst/>
           </a:prstGeom>
           <a:solidFill>
-            <a:schemeClr val="accent1"/>
+            <a:srgbClr val="E8541E"/>
           </a:solidFill>
           <a:ln/>
         </p:spPr>
@@ -13469,7 +13357,7 @@
       <p:sp>
         <p:nvSpPr>
           <p:cNvPr id="8007" name="box 189"/>
-          <p:cNvSpPr/>
+          <p:cNvSpPr txBox="1"/>
           <p:nvPr/>
         </p:nvSpPr>
         <p:spPr>
@@ -13477,13 +13365,11 @@
             <a:off x="457200" y="1969008"/>
             <a:ext cx="2194560" cy="731520"/>
           </a:xfrm>
-          <a:prstGeom prst="roundRect">
-            <a:avLst>
-              <a:gd name="adj" fmla="val 10000"/>
-            </a:avLst>
+          <a:prstGeom prst="rect">
+            <a:avLst/>
           </a:prstGeom>
           <a:solidFill>
-            <a:schemeClr val="accent2"/>
+            <a:srgbClr val="1F5FA8"/>
           </a:solidFill>
           <a:ln/>
         </p:spPr>
@@ -13571,7 +13457,7 @@
       <p:sp>
         <p:nvSpPr>
           <p:cNvPr id="8010" name="box 192"/>
-          <p:cNvSpPr/>
+          <p:cNvSpPr txBox="1"/>
           <p:nvPr/>
         </p:nvSpPr>
         <p:spPr>
@@ -13579,13 +13465,11 @@
             <a:off x="3108960" y="1969008"/>
             <a:ext cx="2377440" cy="731520"/>
           </a:xfrm>
-          <a:prstGeom prst="roundRect">
-            <a:avLst>
-              <a:gd name="adj" fmla="val 10000"/>
-            </a:avLst>
+          <a:prstGeom prst="rect">
+            <a:avLst/>
           </a:prstGeom>
           <a:solidFill>
-            <a:schemeClr val="accent4"/>
+            <a:srgbClr val="3E4C66"/>
           </a:solidFill>
           <a:ln/>
         </p:spPr>
@@ -13673,7 +13557,7 @@
       <p:sp>
         <p:nvSpPr>
           <p:cNvPr id="8013" name="box 195"/>
-          <p:cNvSpPr/>
+          <p:cNvSpPr txBox="1"/>
           <p:nvPr/>
         </p:nvSpPr>
         <p:spPr>
@@ -13681,13 +13565,11 @@
             <a:off x="5943600" y="1969008"/>
             <a:ext cx="2743200" cy="731520"/>
           </a:xfrm>
-          <a:prstGeom prst="roundRect">
-            <a:avLst>
-              <a:gd name="adj" fmla="val 10000"/>
-            </a:avLst>
+          <a:prstGeom prst="rect">
+            <a:avLst/>
           </a:prstGeom>
           <a:solidFill>
-            <a:schemeClr val="accent1"/>
+            <a:srgbClr val="E8541E"/>
           </a:solidFill>
           <a:ln/>
         </p:spPr>
@@ -13751,7 +13633,7 @@
       <p:sp>
         <p:nvSpPr>
           <p:cNvPr id="8015" name="box 197"/>
-          <p:cNvSpPr/>
+          <p:cNvSpPr txBox="1"/>
           <p:nvPr/>
         </p:nvSpPr>
         <p:spPr>
@@ -13759,13 +13641,11 @@
             <a:off x="457200" y="2929128"/>
             <a:ext cx="2194560" cy="731520"/>
           </a:xfrm>
-          <a:prstGeom prst="roundRect">
-            <a:avLst>
-              <a:gd name="adj" fmla="val 10000"/>
-            </a:avLst>
+          <a:prstGeom prst="rect">
+            <a:avLst/>
           </a:prstGeom>
           <a:solidFill>
-            <a:schemeClr val="accent2"/>
+            <a:srgbClr val="1F5FA8"/>
           </a:solidFill>
           <a:ln/>
         </p:spPr>
@@ -13853,7 +13733,7 @@
       <p:sp>
         <p:nvSpPr>
           <p:cNvPr id="8018" name="box 200"/>
-          <p:cNvSpPr/>
+          <p:cNvSpPr txBox="1"/>
           <p:nvPr/>
         </p:nvSpPr>
         <p:spPr>
@@ -13861,13 +13741,11 @@
             <a:off x="3108960" y="2929128"/>
             <a:ext cx="2377440" cy="731520"/>
           </a:xfrm>
-          <a:prstGeom prst="roundRect">
-            <a:avLst>
-              <a:gd name="adj" fmla="val 10000"/>
-            </a:avLst>
+          <a:prstGeom prst="rect">
+            <a:avLst/>
           </a:prstGeom>
           <a:solidFill>
-            <a:schemeClr val="accent4"/>
+            <a:srgbClr val="3E4C66"/>
           </a:solidFill>
           <a:ln/>
         </p:spPr>
@@ -13955,7 +13833,7 @@
       <p:sp>
         <p:nvSpPr>
           <p:cNvPr id="8021" name="box 203"/>
-          <p:cNvSpPr/>
+          <p:cNvSpPr txBox="1"/>
           <p:nvPr/>
         </p:nvSpPr>
         <p:spPr>
@@ -13963,13 +13841,11 @@
             <a:off x="5943600" y="2929128"/>
             <a:ext cx="2743200" cy="731520"/>
           </a:xfrm>
-          <a:prstGeom prst="roundRect">
-            <a:avLst>
-              <a:gd name="adj" fmla="val 10000"/>
-            </a:avLst>
+          <a:prstGeom prst="rect">
+            <a:avLst/>
           </a:prstGeom>
           <a:solidFill>
-            <a:schemeClr val="accent3"/>
+            <a:srgbClr val="2E7D32"/>
           </a:solidFill>
           <a:ln/>
         </p:spPr>
@@ -14033,7 +13909,7 @@
       <p:sp>
         <p:nvSpPr>
           <p:cNvPr id="8023" name="fallback bar 205"/>
-          <p:cNvSpPr/>
+          <p:cNvSpPr txBox="1"/>
           <p:nvPr/>
         </p:nvSpPr>
         <p:spPr>
@@ -14041,13 +13917,11 @@
             <a:off x="457200" y="3934968"/>
             <a:ext cx="8229600" cy="457200"/>
           </a:xfrm>
-          <a:prstGeom prst="roundRect">
-            <a:avLst>
-              <a:gd name="adj" fmla="val 16000"/>
-            </a:avLst>
+          <a:prstGeom prst="rect">
+            <a:avLst/>
           </a:prstGeom>
           <a:solidFill>
-            <a:schemeClr val="accent6"/>
+            <a:srgbClr val="FFE6D9"/>
           </a:solidFill>
           <a:ln/>
         </p:spPr>
@@ -14208,7 +14082,7 @@
       <p:sp>
         <p:nvSpPr>
           <p:cNvPr id="9003" name="table header 207"/>
-          <p:cNvSpPr/>
+          <p:cNvSpPr txBox="1"/>
           <p:nvPr/>
         </p:nvSpPr>
         <p:spPr>
@@ -14216,13 +14090,11 @@
             <a:off x="457200" y="1051560"/>
             <a:ext cx="8229600" cy="365760"/>
           </a:xfrm>
-          <a:prstGeom prst="roundRect">
-            <a:avLst>
-              <a:gd name="adj" fmla="val 15000"/>
-            </a:avLst>
+          <a:prstGeom prst="rect">
+            <a:avLst/>
           </a:prstGeom>
           <a:solidFill>
-            <a:schemeClr val="tx1"/>
+            <a:srgbClr val="1B2535"/>
           </a:solidFill>
           <a:ln/>
         </p:spPr>
@@ -14503,7 +14375,7 @@
       <p:sp>
         <p:nvSpPr>
           <p:cNvPr id="9011" name="done pill 215"/>
-          <p:cNvSpPr/>
+          <p:cNvSpPr txBox="1"/>
           <p:nvPr/>
         </p:nvSpPr>
         <p:spPr>
@@ -14511,13 +14383,11 @@
             <a:off x="8014716" y="1490472"/>
             <a:ext cx="566928" cy="219456"/>
           </a:xfrm>
-          <a:prstGeom prst="roundRect">
-            <a:avLst>
-              <a:gd name="adj" fmla="val 50000"/>
-            </a:avLst>
+          <a:prstGeom prst="rect">
+            <a:avLst/>
           </a:prstGeom>
           <a:solidFill>
-            <a:schemeClr val="accent3"/>
+            <a:srgbClr val="2E7D32"/>
           </a:solidFill>
           <a:ln/>
         </p:spPr>
@@ -14564,7 +14434,7 @@
       <p:sp>
         <p:nvSpPr>
           <p:cNvPr id="9013" name="table row 217"/>
-          <p:cNvSpPr/>
+          <p:cNvSpPr txBox="1"/>
           <p:nvPr/>
         </p:nvSpPr>
         <p:spPr>
@@ -14576,7 +14446,7 @@
             <a:avLst/>
           </a:prstGeom>
           <a:solidFill>
-            <a:schemeClr val="bg2"/>
+            <a:srgbClr val="F3F5F9"/>
           </a:solidFill>
           <a:ln/>
         </p:spPr>
@@ -14701,7 +14571,7 @@
       <p:sp>
         <p:nvSpPr>
           <p:cNvPr id="9017" name="done pill 221"/>
-          <p:cNvSpPr/>
+          <p:cNvSpPr txBox="1"/>
           <p:nvPr/>
         </p:nvSpPr>
         <p:spPr>
@@ -14709,13 +14579,11 @@
             <a:off x="8014716" y="1856232"/>
             <a:ext cx="566928" cy="219456"/>
           </a:xfrm>
-          <a:prstGeom prst="roundRect">
-            <a:avLst>
-              <a:gd name="adj" fmla="val 50000"/>
-            </a:avLst>
+          <a:prstGeom prst="rect">
+            <a:avLst/>
           </a:prstGeom>
           <a:solidFill>
-            <a:schemeClr val="accent3"/>
+            <a:srgbClr val="2E7D32"/>
           </a:solidFill>
           <a:ln/>
         </p:spPr>
@@ -14879,7 +14747,7 @@
       <p:sp>
         <p:nvSpPr>
           <p:cNvPr id="9022" name="done pill 226"/>
-          <p:cNvSpPr/>
+          <p:cNvSpPr txBox="1"/>
           <p:nvPr/>
         </p:nvSpPr>
         <p:spPr>
@@ -14887,13 +14755,11 @@
             <a:off x="8014716" y="2221992"/>
             <a:ext cx="566928" cy="219456"/>
           </a:xfrm>
-          <a:prstGeom prst="roundRect">
-            <a:avLst>
-              <a:gd name="adj" fmla="val 50000"/>
-            </a:avLst>
+          <a:prstGeom prst="rect">
+            <a:avLst/>
           </a:prstGeom>
           <a:solidFill>
-            <a:schemeClr val="accent3"/>
+            <a:srgbClr val="2E7D32"/>
           </a:solidFill>
           <a:ln/>
         </p:spPr>
@@ -14940,7 +14806,7 @@
       <p:sp>
         <p:nvSpPr>
           <p:cNvPr id="9024" name="table row 228"/>
-          <p:cNvSpPr/>
+          <p:cNvSpPr txBox="1"/>
           <p:nvPr/>
         </p:nvSpPr>
         <p:spPr>
@@ -14952,7 +14818,7 @@
             <a:avLst/>
           </a:prstGeom>
           <a:solidFill>
-            <a:schemeClr val="bg2"/>
+            <a:srgbClr val="F3F5F9"/>
           </a:solidFill>
           <a:ln/>
         </p:spPr>
@@ -15077,7 +14943,7 @@
       <p:sp>
         <p:nvSpPr>
           <p:cNvPr id="9028" name="done pill 232"/>
-          <p:cNvSpPr/>
+          <p:cNvSpPr txBox="1"/>
           <p:nvPr/>
         </p:nvSpPr>
         <p:spPr>
@@ -15085,13 +14951,11 @@
             <a:off x="8014716" y="2587752"/>
             <a:ext cx="566928" cy="219456"/>
           </a:xfrm>
-          <a:prstGeom prst="roundRect">
-            <a:avLst>
-              <a:gd name="adj" fmla="val 50000"/>
-            </a:avLst>
+          <a:prstGeom prst="rect">
+            <a:avLst/>
           </a:prstGeom>
           <a:solidFill>
-            <a:schemeClr val="accent3"/>
+            <a:srgbClr val="2E7D32"/>
           </a:solidFill>
           <a:ln/>
         </p:spPr>
@@ -15255,7 +15119,7 @@
       <p:sp>
         <p:nvSpPr>
           <p:cNvPr id="9033" name="done pill 237"/>
-          <p:cNvSpPr/>
+          <p:cNvSpPr txBox="1"/>
           <p:nvPr/>
         </p:nvSpPr>
         <p:spPr>
@@ -15263,13 +15127,11 @@
             <a:off x="8014716" y="2953512"/>
             <a:ext cx="566928" cy="219456"/>
           </a:xfrm>
-          <a:prstGeom prst="roundRect">
-            <a:avLst>
-              <a:gd name="adj" fmla="val 50000"/>
-            </a:avLst>
+          <a:prstGeom prst="rect">
+            <a:avLst/>
           </a:prstGeom>
           <a:solidFill>
-            <a:schemeClr val="accent3"/>
+            <a:srgbClr val="2E7D32"/>
           </a:solidFill>
           <a:ln/>
         </p:spPr>
@@ -15316,7 +15178,7 @@
       <p:sp>
         <p:nvSpPr>
           <p:cNvPr id="9035" name="table row 239"/>
-          <p:cNvSpPr/>
+          <p:cNvSpPr txBox="1"/>
           <p:nvPr/>
         </p:nvSpPr>
         <p:spPr>
@@ -15328,7 +15190,7 @@
             <a:avLst/>
           </a:prstGeom>
           <a:solidFill>
-            <a:schemeClr val="bg2"/>
+            <a:srgbClr val="F3F5F9"/>
           </a:solidFill>
           <a:ln/>
         </p:spPr>
@@ -15453,7 +15315,7 @@
       <p:sp>
         <p:nvSpPr>
           <p:cNvPr id="9039" name="done pill 243"/>
-          <p:cNvSpPr/>
+          <p:cNvSpPr txBox="1"/>
           <p:nvPr/>
         </p:nvSpPr>
         <p:spPr>
@@ -15461,13 +15323,11 @@
             <a:off x="8014716" y="3319272"/>
             <a:ext cx="566928" cy="219456"/>
           </a:xfrm>
-          <a:prstGeom prst="roundRect">
-            <a:avLst>
-              <a:gd name="adj" fmla="val 50000"/>
-            </a:avLst>
+          <a:prstGeom prst="rect">
+            <a:avLst/>
           </a:prstGeom>
           <a:solidFill>
-            <a:schemeClr val="accent3"/>
+            <a:srgbClr val="2E7D32"/>
           </a:solidFill>
           <a:ln/>
         </p:spPr>
@@ -15631,7 +15491,7 @@
       <p:sp>
         <p:nvSpPr>
           <p:cNvPr id="9044" name="done pill 248"/>
-          <p:cNvSpPr/>
+          <p:cNvSpPr txBox="1"/>
           <p:nvPr/>
         </p:nvSpPr>
         <p:spPr>
@@ -15639,13 +15499,11 @@
             <a:off x="8014716" y="3685032"/>
             <a:ext cx="566928" cy="219456"/>
           </a:xfrm>
-          <a:prstGeom prst="roundRect">
-            <a:avLst>
-              <a:gd name="adj" fmla="val 50000"/>
-            </a:avLst>
+          <a:prstGeom prst="rect">
+            <a:avLst/>
           </a:prstGeom>
           <a:solidFill>
-            <a:schemeClr val="accent3"/>
+            <a:srgbClr val="2E7D32"/>
           </a:solidFill>
           <a:ln/>
         </p:spPr>
@@ -15692,7 +15550,7 @@
       <p:sp>
         <p:nvSpPr>
           <p:cNvPr id="9046" name="table row 250"/>
-          <p:cNvSpPr/>
+          <p:cNvSpPr txBox="1"/>
           <p:nvPr/>
         </p:nvSpPr>
         <p:spPr>
@@ -15704,7 +15562,7 @@
             <a:avLst/>
           </a:prstGeom>
           <a:solidFill>
-            <a:schemeClr val="bg2"/>
+            <a:srgbClr val="F3F5F9"/>
           </a:solidFill>
           <a:ln/>
         </p:spPr>
@@ -15829,7 +15687,7 @@
       <p:sp>
         <p:nvSpPr>
           <p:cNvPr id="9050" name="done pill 254"/>
-          <p:cNvSpPr/>
+          <p:cNvSpPr txBox="1"/>
           <p:nvPr/>
         </p:nvSpPr>
         <p:spPr>
@@ -15837,13 +15695,11 @@
             <a:off x="8014716" y="4050792"/>
             <a:ext cx="566928" cy="219456"/>
           </a:xfrm>
-          <a:prstGeom prst="roundRect">
-            <a:avLst>
-              <a:gd name="adj" fmla="val 50000"/>
-            </a:avLst>
+          <a:prstGeom prst="rect">
+            <a:avLst/>
           </a:prstGeom>
           <a:solidFill>
-            <a:schemeClr val="accent3"/>
+            <a:srgbClr val="2E7D32"/>
           </a:solidFill>
           <a:ln/>
         </p:spPr>

</xml_diff>